<commit_message>
fix(presentation): update clean logo and crisp vector arrows in flowchart on Slide 3
</commit_message>
<xml_diff>
--- a/AirIntel_India_SIH26056_Presentation.pptx
+++ b/AirIntel_India_SIH26056_Presentation.pptx
@@ -3175,7 +3175,7 @@
       </p:sp>
       <p:pic>
         <p:nvPicPr>
-          <p:cNvPr id="4" name="Picture 3" descr="page_1_img_2.png"/>
+          <p:cNvPr id="4" name="Picture 3" descr="clean_sih_logo.png"/>
           <p:cNvPicPr>
             <a:picLocks noChangeAspect="1"/>
           </p:cNvPicPr>
@@ -3561,7 +3561,7 @@
       </p:sp>
       <p:pic>
         <p:nvPicPr>
-          <p:cNvPr id="5" name="Picture 4" descr="page_1_img_2.png"/>
+          <p:cNvPr id="5" name="Picture 4" descr="clean_sih_logo.png"/>
           <p:cNvPicPr>
             <a:picLocks noChangeAspect="1"/>
           </p:cNvPicPr>
@@ -3740,7 +3740,7 @@
         <p:spPr>
           <a:xfrm>
             <a:off x="4297680" y="1325880"/>
-            <a:ext cx="1097280" cy="502920"/>
+            <a:ext cx="877824" cy="502920"/>
           </a:xfrm>
           <a:prstGeom prst="roundRect">
             <a:avLst/>
@@ -3773,15 +3773,15 @@
           <a:lstStyle/>
           <a:p>
             <a:pPr algn="ctr">
-              <a:defRPr sz="950" b="1">
-                <a:solidFill>
-                  <a:srgbClr val="000000"/>
-                </a:solidFill>
-                <a:latin typeface="Arial"/>
-              </a:defRPr>
-            </a:pPr>
-            <a:r>
-              <a:t>Scheduled Harvest</a:t>
+              <a:defRPr sz="1000" b="1">
+                <a:solidFill>
+                  <a:srgbClr val="000000"/>
+                </a:solidFill>
+                <a:latin typeface="Arial"/>
+              </a:defRPr>
+            </a:pPr>
+            <a:r>
+              <a:t>1. Ingestion</a:t>
             </a:r>
           </a:p>
         </p:txBody>
@@ -3794,8 +3794,8 @@
         </p:nvSpPr>
         <p:spPr>
           <a:xfrm>
-            <a:off x="5504688" y="1325880"/>
-            <a:ext cx="1097280" cy="502920"/>
+            <a:off x="5285232" y="1325880"/>
+            <a:ext cx="877824" cy="502920"/>
           </a:xfrm>
           <a:prstGeom prst="roundRect">
             <a:avLst/>
@@ -3828,15 +3828,15 @@
           <a:lstStyle/>
           <a:p>
             <a:pPr algn="ctr">
-              <a:defRPr sz="950" b="1">
-                <a:solidFill>
-                  <a:srgbClr val="000000"/>
-                </a:solidFill>
-                <a:latin typeface="Arial"/>
-              </a:defRPr>
-            </a:pPr>
-            <a:r>
-              <a:t>Normalization</a:t>
+              <a:defRPr sz="1000" b="1">
+                <a:solidFill>
+                  <a:srgbClr val="000000"/>
+                </a:solidFill>
+                <a:latin typeface="Arial"/>
+              </a:defRPr>
+            </a:pPr>
+            <a:r>
+              <a:t>2. Cleanse</a:t>
             </a:r>
           </a:p>
         </p:txBody>
@@ -3849,8 +3849,8 @@
         </p:nvSpPr>
         <p:spPr>
           <a:xfrm>
-            <a:off x="6711696" y="1325880"/>
-            <a:ext cx="1097280" cy="502920"/>
+            <a:off x="6272784" y="1325880"/>
+            <a:ext cx="877824" cy="502920"/>
           </a:xfrm>
           <a:prstGeom prst="roundRect">
             <a:avLst/>
@@ -3883,15 +3883,15 @@
           <a:lstStyle/>
           <a:p>
             <a:pPr algn="ctr">
-              <a:defRPr sz="950" b="1">
-                <a:solidFill>
-                  <a:srgbClr val="000000"/>
-                </a:solidFill>
-                <a:latin typeface="Arial"/>
-              </a:defRPr>
-            </a:pPr>
-            <a:r>
-              <a:t>Z-Score Filter</a:t>
+              <a:defRPr sz="1000" b="1">
+                <a:solidFill>
+                  <a:srgbClr val="000000"/>
+                </a:solidFill>
+                <a:latin typeface="Arial"/>
+              </a:defRPr>
+            </a:pPr>
+            <a:r>
+              <a:t>3. Jevons GM</a:t>
             </a:r>
           </a:p>
         </p:txBody>
@@ -3904,8 +3904,8 @@
         </p:nvSpPr>
         <p:spPr>
           <a:xfrm>
-            <a:off x="7918704" y="1325880"/>
-            <a:ext cx="1097280" cy="502920"/>
+            <a:off x="7260336" y="1325880"/>
+            <a:ext cx="877824" cy="502920"/>
           </a:xfrm>
           <a:prstGeom prst="roundRect">
             <a:avLst/>
@@ -3938,15 +3938,15 @@
           <a:lstStyle/>
           <a:p>
             <a:pPr algn="ctr">
-              <a:defRPr sz="950" b="1">
-                <a:solidFill>
-                  <a:srgbClr val="000000"/>
-                </a:solidFill>
-                <a:latin typeface="Arial"/>
-              </a:defRPr>
-            </a:pPr>
-            <a:r>
-              <a:t>Jevons GM</a:t>
+              <a:defRPr sz="1000" b="1">
+                <a:solidFill>
+                  <a:srgbClr val="000000"/>
+                </a:solidFill>
+                <a:latin typeface="Arial"/>
+              </a:defRPr>
+            </a:pPr>
+            <a:r>
+              <a:t>4. Laspeyres</a:t>
             </a:r>
           </a:p>
         </p:txBody>
@@ -3954,116 +3954,6 @@
       <p:sp>
         <p:nvSpPr>
           <p:cNvPr id="12" name="Rounded Rectangle 11"/>
-          <p:cNvSpPr/>
-          <p:nvPr/>
-        </p:nvSpPr>
-        <p:spPr>
-          <a:xfrm>
-            <a:off x="9125712" y="1325880"/>
-            <a:ext cx="1097280" cy="502920"/>
-          </a:xfrm>
-          <a:prstGeom prst="roundRect">
-            <a:avLst/>
-          </a:prstGeom>
-          <a:solidFill>
-            <a:srgbClr val="DBEAFE"/>
-          </a:solidFill>
-          <a:ln w="12700">
-            <a:solidFill>
-              <a:srgbClr val="6366F1"/>
-            </a:solidFill>
-          </a:ln>
-        </p:spPr>
-        <p:style>
-          <a:lnRef idx="1">
-            <a:schemeClr val="accent1"/>
-          </a:lnRef>
-          <a:fillRef idx="3">
-            <a:schemeClr val="accent1"/>
-          </a:fillRef>
-          <a:effectRef idx="2">
-            <a:schemeClr val="accent1"/>
-          </a:effectRef>
-          <a:fontRef idx="minor">
-            <a:schemeClr val="lt1"/>
-          </a:fontRef>
-        </p:style>
-        <p:txBody>
-          <a:bodyPr rtlCol="0" anchor="ctr"/>
-          <a:lstStyle/>
-          <a:p>
-            <a:pPr algn="ctr">
-              <a:defRPr sz="950" b="1">
-                <a:solidFill>
-                  <a:srgbClr val="000000"/>
-                </a:solidFill>
-                <a:latin typeface="Arial"/>
-              </a:defRPr>
-            </a:pPr>
-            <a:r>
-              <a:t>Laspeyres</a:t>
-            </a:r>
-          </a:p>
-        </p:txBody>
-      </p:sp>
-      <p:sp>
-        <p:nvSpPr>
-          <p:cNvPr id="13" name="Rounded Rectangle 12"/>
-          <p:cNvSpPr/>
-          <p:nvPr/>
-        </p:nvSpPr>
-        <p:spPr>
-          <a:xfrm>
-            <a:off x="10332720" y="1325880"/>
-            <a:ext cx="1097280" cy="502920"/>
-          </a:xfrm>
-          <a:prstGeom prst="roundRect">
-            <a:avLst/>
-          </a:prstGeom>
-          <a:solidFill>
-            <a:srgbClr val="E9D5FF"/>
-          </a:solidFill>
-          <a:ln w="12700">
-            <a:solidFill>
-              <a:srgbClr val="6366F1"/>
-            </a:solidFill>
-          </a:ln>
-        </p:spPr>
-        <p:style>
-          <a:lnRef idx="1">
-            <a:schemeClr val="accent1"/>
-          </a:lnRef>
-          <a:fillRef idx="3">
-            <a:schemeClr val="accent1"/>
-          </a:fillRef>
-          <a:effectRef idx="2">
-            <a:schemeClr val="accent1"/>
-          </a:effectRef>
-          <a:fontRef idx="minor">
-            <a:schemeClr val="lt1"/>
-          </a:fontRef>
-        </p:style>
-        <p:txBody>
-          <a:bodyPr rtlCol="0" anchor="ctr"/>
-          <a:lstStyle/>
-          <a:p>
-            <a:pPr algn="ctr">
-              <a:defRPr sz="950" b="1">
-                <a:solidFill>
-                  <a:srgbClr val="000000"/>
-                </a:solidFill>
-                <a:latin typeface="Arial"/>
-              </a:defRPr>
-            </a:pPr>
-            <a:r>
-              <a:t>Dashboard</a:t>
-            </a:r>
-          </a:p>
-        </p:txBody>
-      </p:sp>
-      <p:sp>
-        <p:nvSpPr>
-          <p:cNvPr id="14" name="Rounded Rectangle 13"/>
           <p:cNvSpPr/>
           <p:nvPr/>
         </p:nvSpPr>
@@ -4108,7 +3998,7 @@
       </p:sp>
       <p:sp>
         <p:nvSpPr>
-          <p:cNvPr id="15" name="TextBox 14"/>
+          <p:cNvPr id="13" name="TextBox 12"/>
           <p:cNvSpPr txBox="1"/>
           <p:nvPr/>
         </p:nvSpPr>
@@ -4256,7 +4146,7 @@
       </p:sp>
       <p:sp>
         <p:nvSpPr>
-          <p:cNvPr id="16" name="Rounded Rectangle 15"/>
+          <p:cNvPr id="14" name="Rounded Rectangle 13"/>
           <p:cNvSpPr/>
           <p:nvPr/>
         </p:nvSpPr>
@@ -4301,7 +4191,7 @@
       </p:sp>
       <p:sp>
         <p:nvSpPr>
-          <p:cNvPr id="17" name="TextBox 16"/>
+          <p:cNvPr id="15" name="TextBox 14"/>
           <p:cNvSpPr txBox="1"/>
           <p:nvPr/>
         </p:nvSpPr>
@@ -4388,7 +4278,7 @@
       </p:sp>
       <p:sp>
         <p:nvSpPr>
-          <p:cNvPr id="18" name="Rounded Rectangle 17"/>
+          <p:cNvPr id="16" name="Rounded Rectangle 15"/>
           <p:cNvSpPr/>
           <p:nvPr/>
         </p:nvSpPr>
@@ -4433,7 +4323,7 @@
       </p:sp>
       <p:sp>
         <p:nvSpPr>
-          <p:cNvPr id="19" name="TextBox 18"/>
+          <p:cNvPr id="17" name="TextBox 16"/>
           <p:cNvSpPr txBox="1"/>
           <p:nvPr/>
         </p:nvSpPr>
@@ -4672,7 +4562,7 @@
       </p:sp>
       <p:pic>
         <p:nvPicPr>
-          <p:cNvPr id="5" name="Picture 4" descr="page_1_img_2.png"/>
+          <p:cNvPr id="5" name="Picture 4" descr="clean_sih_logo.png"/>
           <p:cNvPicPr>
             <a:picLocks noChangeAspect="1"/>
           </p:cNvPicPr>
@@ -5278,7 +5168,7 @@
       </p:sp>
       <p:pic>
         <p:nvPicPr>
-          <p:cNvPr id="5" name="Picture 4" descr="page_1_img_2.png"/>
+          <p:cNvPr id="5" name="Picture 4" descr="clean_sih_logo.png"/>
           <p:cNvPicPr>
             <a:picLocks noChangeAspect="1"/>
           </p:cNvPicPr>
@@ -6128,7 +6018,7 @@
       </p:sp>
       <p:pic>
         <p:nvPicPr>
-          <p:cNvPr id="5" name="Picture 4" descr="page_1_img_2.png"/>
+          <p:cNvPr id="5" name="Picture 4" descr="clean_sih_logo.png"/>
           <p:cNvPicPr>
             <a:picLocks noChangeAspect="1"/>
           </p:cNvPicPr>
@@ -6943,7 +6833,7 @@
       </p:sp>
       <p:pic>
         <p:nvPicPr>
-          <p:cNvPr id="5" name="Picture 4" descr="page_1_img_2.png"/>
+          <p:cNvPr id="5" name="Picture 4" descr="clean_sih_logo.png"/>
           <p:cNvPicPr>
             <a:picLocks noChangeAspect="1"/>
           </p:cNvPicPr>
@@ -7233,7 +7123,7 @@
       </p:sp>
       <p:pic>
         <p:nvPicPr>
-          <p:cNvPr id="4" name="Picture 3" descr="page_1_img_2.png"/>
+          <p:cNvPr id="4" name="Picture 3" descr="clean_sih_logo.png"/>
           <p:cNvPicPr>
             <a:picLocks noChangeAspect="1"/>
           </p:cNvPicPr>

</xml_diff>

<commit_message>
feat(presentation): upgrade all slides to Ultra-HD assets, replace 2022 logo with official SIH 2026 emblem
</commit_message>
<xml_diff>
--- a/AirIntel_India_SIH26056_Presentation.pptx
+++ b/AirIntel_India_SIH26056_Presentation.pptx
@@ -3145,8 +3145,8 @@
         </p:nvSpPr>
         <p:spPr>
           <a:xfrm>
-            <a:off x="914400" y="457200"/>
-            <a:ext cx="8686800" cy="1097280"/>
+            <a:off x="731520" y="365760"/>
+            <a:ext cx="8961120" cy="1097280"/>
           </a:xfrm>
           <a:prstGeom prst="rect">
             <a:avLst/>
@@ -3175,7 +3175,7 @@
       </p:sp>
       <p:pic>
         <p:nvPicPr>
-          <p:cNvPr id="4" name="Picture 3" descr="clean_sih_logo.png"/>
+          <p:cNvPr id="4" name="Picture 3" descr="sih_2026_logo_hd.png"/>
           <p:cNvPicPr>
             <a:picLocks noChangeAspect="1"/>
           </p:cNvPicPr>
@@ -3189,8 +3189,8 @@
         </p:blipFill>
         <p:spPr>
           <a:xfrm>
-            <a:off x="10058400" y="274320"/>
-            <a:ext cx="1737360" cy="914400"/>
+            <a:off x="10058400" y="182880"/>
+            <a:ext cx="1828800" cy="914400"/>
           </a:xfrm>
           <a:prstGeom prst="rect">
             <a:avLst/>
@@ -3199,7 +3199,7 @@
       </p:pic>
       <p:pic>
         <p:nvPicPr>
-          <p:cNvPr id="5" name="Picture 4" descr="page_1_img_1.png"/>
+          <p:cNvPr id="5" name="Picture 4" descr="sih_cover_badge_hd.png"/>
           <p:cNvPicPr>
             <a:picLocks noChangeAspect="1"/>
           </p:cNvPicPr>
@@ -3213,8 +3213,8 @@
         </p:blipFill>
         <p:spPr>
           <a:xfrm>
-            <a:off x="7772400" y="1645920"/>
-            <a:ext cx="3931920" cy="4389120"/>
+            <a:off x="7589520" y="1280160"/>
+            <a:ext cx="4114800" cy="5029200"/>
           </a:xfrm>
           <a:prstGeom prst="rect">
             <a:avLst/>
@@ -3561,7 +3561,7 @@
       </p:sp>
       <p:pic>
         <p:nvPicPr>
-          <p:cNvPr id="5" name="Picture 4" descr="clean_sih_logo.png"/>
+          <p:cNvPr id="5" name="Picture 4" descr="sih_2026_logo_hd.png"/>
           <p:cNvPicPr>
             <a:picLocks noChangeAspect="1"/>
           </p:cNvPicPr>
@@ -3575,8 +3575,8 @@
         </p:blipFill>
         <p:spPr>
           <a:xfrm>
-            <a:off x="10241280" y="164592"/>
-            <a:ext cx="1645920" cy="868680"/>
+            <a:off x="10058400" y="146304"/>
+            <a:ext cx="1828800" cy="914400"/>
           </a:xfrm>
           <a:prstGeom prst="rect">
             <a:avLst/>
@@ -4562,7 +4562,7 @@
       </p:sp>
       <p:pic>
         <p:nvPicPr>
-          <p:cNvPr id="5" name="Picture 4" descr="clean_sih_logo.png"/>
+          <p:cNvPr id="5" name="Picture 4" descr="sih_2026_logo_hd.png"/>
           <p:cNvPicPr>
             <a:picLocks noChangeAspect="1"/>
           </p:cNvPicPr>
@@ -4576,8 +4576,8 @@
         </p:blipFill>
         <p:spPr>
           <a:xfrm>
-            <a:off x="10241280" y="164592"/>
-            <a:ext cx="1645920" cy="868680"/>
+            <a:off x="10058400" y="146304"/>
+            <a:ext cx="1828800" cy="914400"/>
           </a:xfrm>
           <a:prstGeom prst="rect">
             <a:avLst/>
@@ -5168,7 +5168,7 @@
       </p:sp>
       <p:pic>
         <p:nvPicPr>
-          <p:cNvPr id="5" name="Picture 4" descr="clean_sih_logo.png"/>
+          <p:cNvPr id="5" name="Picture 4" descr="sih_2026_logo_hd.png"/>
           <p:cNvPicPr>
             <a:picLocks noChangeAspect="1"/>
           </p:cNvPicPr>
@@ -5182,8 +5182,8 @@
         </p:blipFill>
         <p:spPr>
           <a:xfrm>
-            <a:off x="10241280" y="164592"/>
-            <a:ext cx="1645920" cy="868680"/>
+            <a:off x="10058400" y="146304"/>
+            <a:ext cx="1828800" cy="914400"/>
           </a:xfrm>
           <a:prstGeom prst="rect">
             <a:avLst/>
@@ -6018,7 +6018,7 @@
       </p:sp>
       <p:pic>
         <p:nvPicPr>
-          <p:cNvPr id="5" name="Picture 4" descr="clean_sih_logo.png"/>
+          <p:cNvPr id="5" name="Picture 4" descr="sih_2026_logo_hd.png"/>
           <p:cNvPicPr>
             <a:picLocks noChangeAspect="1"/>
           </p:cNvPicPr>
@@ -6032,8 +6032,8 @@
         </p:blipFill>
         <p:spPr>
           <a:xfrm>
-            <a:off x="10241280" y="164592"/>
-            <a:ext cx="1645920" cy="868680"/>
+            <a:off x="10058400" y="146304"/>
+            <a:ext cx="1828800" cy="914400"/>
           </a:xfrm>
           <a:prstGeom prst="rect">
             <a:avLst/>
@@ -6833,7 +6833,7 @@
       </p:sp>
       <p:pic>
         <p:nvPicPr>
-          <p:cNvPr id="5" name="Picture 4" descr="clean_sih_logo.png"/>
+          <p:cNvPr id="5" name="Picture 4" descr="sih_2026_logo_hd.png"/>
           <p:cNvPicPr>
             <a:picLocks noChangeAspect="1"/>
           </p:cNvPicPr>
@@ -6847,8 +6847,8 @@
         </p:blipFill>
         <p:spPr>
           <a:xfrm>
-            <a:off x="10241280" y="164592"/>
-            <a:ext cx="1645920" cy="868680"/>
+            <a:off x="10058400" y="146304"/>
+            <a:ext cx="1828800" cy="914400"/>
           </a:xfrm>
           <a:prstGeom prst="rect">
             <a:avLst/>
@@ -6929,7 +6929,7 @@
       </p:sp>
       <p:pic>
         <p:nvPicPr>
-          <p:cNvPr id="8" name="Picture 7" descr="demo_chart_screenshot.png"/>
+          <p:cNvPr id="8" name="Picture 7" descr="demo_chart_hd.png"/>
           <p:cNvPicPr>
             <a:picLocks noChangeAspect="1"/>
           </p:cNvPicPr>
@@ -6943,8 +6943,8 @@
         </p:blipFill>
         <p:spPr>
           <a:xfrm>
-            <a:off x="548640" y="1645920"/>
-            <a:ext cx="5303520" cy="3931920"/>
+            <a:off x="548640" y="1600200"/>
+            <a:ext cx="5394960" cy="3154680"/>
           </a:xfrm>
           <a:prstGeom prst="rect">
             <a:avLst/>
@@ -6953,7 +6953,7 @@
       </p:pic>
       <p:pic>
         <p:nvPicPr>
-          <p:cNvPr id="9" name="Picture 8" descr="media_1789662269891.png"/>
+          <p:cNvPr id="9" name="Picture 8" descr="demo_table_hd.png"/>
           <p:cNvPicPr>
             <a:picLocks noChangeAspect="1"/>
           </p:cNvPicPr>
@@ -6967,8 +6967,8 @@
         </p:blipFill>
         <p:spPr>
           <a:xfrm>
-            <a:off x="6217920" y="1645920"/>
-            <a:ext cx="5394960" cy="3931920"/>
+            <a:off x="6217920" y="1600200"/>
+            <a:ext cx="5394960" cy="3154680"/>
           </a:xfrm>
           <a:prstGeom prst="rect">
             <a:avLst/>
@@ -6983,8 +6983,8 @@
         </p:nvSpPr>
         <p:spPr>
           <a:xfrm>
-            <a:off x="457200" y="5760720"/>
-            <a:ext cx="11277295" cy="822960"/>
+            <a:off x="457200" y="4983480"/>
+            <a:ext cx="11277295" cy="1371600"/>
           </a:xfrm>
           <a:prstGeom prst="rect">
             <a:avLst/>
@@ -7123,7 +7123,7 @@
       </p:sp>
       <p:pic>
         <p:nvPicPr>
-          <p:cNvPr id="4" name="Picture 3" descr="clean_sih_logo.png"/>
+          <p:cNvPr id="4" name="Picture 3" descr="sih_2026_logo_hd.png"/>
           <p:cNvPicPr>
             <a:picLocks noChangeAspect="1"/>
           </p:cNvPicPr>
@@ -7137,8 +7137,8 @@
         </p:blipFill>
         <p:spPr>
           <a:xfrm>
-            <a:off x="10241280" y="164592"/>
-            <a:ext cx="1645920" cy="868680"/>
+            <a:off x="10058400" y="146304"/>
+            <a:ext cx="1828800" cy="914400"/>
           </a:xfrm>
           <a:prstGeom prst="rect">
             <a:avLst/>

</xml_diff>

<commit_message>
feat(presentation): add team members to slide 1 and every slide footer [Nikhil Kanse, Shivish Kumar, Tejas Patil, Pranav Pawale, Harsh Narkar, Blessy]
</commit_message>
<xml_diff>
--- a/AirIntel_India_SIH26056_Presentation.pptx
+++ b/AirIntel_India_SIH26056_Presentation.pptx
@@ -11,7 +11,6 @@
     <p:sldId id="259" r:id="rId10"/>
     <p:sldId id="260" r:id="rId11"/>
     <p:sldId id="261" r:id="rId12"/>
-    <p:sldId id="262" r:id="rId13"/>
   </p:sldIdLst>
   <p:sldSz cx="12191695" cy="6858000" type="screen4x3"/>
   <p:notesSz cx="6858000" cy="9144000"/>
@@ -3229,8 +3228,8 @@
         </p:nvSpPr>
         <p:spPr>
           <a:xfrm>
-            <a:off x="731520" y="1645920"/>
-            <a:ext cx="6858000" cy="4754880"/>
+            <a:off x="731520" y="1508760"/>
+            <a:ext cx="6858000" cy="4892040"/>
           </a:xfrm>
           <a:prstGeom prst="rect">
             <a:avLst/>
@@ -3245,11 +3244,11 @@
           <a:p>
             <a:pPr>
               <a:spcAft>
-                <a:spcPts val="1400"/>
-              </a:spcAft>
-            </a:pPr>
-            <a:r>
-              <a:rPr sz="2000" b="1">
+                <a:spcPts val="800"/>
+              </a:spcAft>
+            </a:pPr>
+            <a:r>
+              <a:rPr sz="1800" b="1">
                 <a:solidFill>
                   <a:srgbClr val="000000"/>
                 </a:solidFill>
@@ -3258,7 +3257,7 @@
               <a:t>• Problem Statement ID – </a:t>
             </a:r>
             <a:r>
-              <a:rPr sz="2000" b="1">
+              <a:rPr sz="1800" b="1">
                 <a:solidFill>
                   <a:srgbClr val="184C94"/>
                 </a:solidFill>
@@ -3270,11 +3269,11 @@
           <a:p>
             <a:pPr>
               <a:spcAft>
-                <a:spcPts val="1400"/>
-              </a:spcAft>
-            </a:pPr>
-            <a:r>
-              <a:rPr sz="1800" b="1">
+                <a:spcPts val="800"/>
+              </a:spcAft>
+            </a:pPr>
+            <a:r>
+              <a:rPr sz="1600" b="1">
                 <a:solidFill>
                   <a:srgbClr val="000000"/>
                 </a:solidFill>
@@ -3283,7 +3282,7 @@
               <a:t>• Problem Statement Title- </a:t>
             </a:r>
             <a:r>
-              <a:rPr sz="1800" b="1">
+              <a:rPr sz="1600" b="1">
                 <a:solidFill>
                   <a:srgbClr val="184C94"/>
                 </a:solidFill>
@@ -3295,11 +3294,11 @@
           <a:p>
             <a:pPr>
               <a:spcAft>
-                <a:spcPts val="1400"/>
-              </a:spcAft>
-            </a:pPr>
-            <a:r>
-              <a:rPr sz="2000" b="1">
+                <a:spcPts val="800"/>
+              </a:spcAft>
+            </a:pPr>
+            <a:r>
+              <a:rPr sz="1800" b="1">
                 <a:solidFill>
                   <a:srgbClr val="000000"/>
                 </a:solidFill>
@@ -3308,7 +3307,7 @@
               <a:t>• Theme- </a:t>
             </a:r>
             <a:r>
-              <a:rPr sz="2000" b="1">
+              <a:rPr sz="1800" b="1">
                 <a:solidFill>
                   <a:srgbClr val="184C94"/>
                 </a:solidFill>
@@ -3320,11 +3319,11 @@
           <a:p>
             <a:pPr>
               <a:spcAft>
-                <a:spcPts val="1400"/>
-              </a:spcAft>
-            </a:pPr>
-            <a:r>
-              <a:rPr sz="2000" b="1">
+                <a:spcPts val="800"/>
+              </a:spcAft>
+            </a:pPr>
+            <a:r>
+              <a:rPr sz="1800" b="1">
                 <a:solidFill>
                   <a:srgbClr val="000000"/>
                 </a:solidFill>
@@ -3333,7 +3332,7 @@
               <a:t>• PS Category- </a:t>
             </a:r>
             <a:r>
-              <a:rPr sz="2000" b="1">
+              <a:rPr sz="1800" b="1">
                 <a:solidFill>
                   <a:srgbClr val="184C94"/>
                 </a:solidFill>
@@ -3345,11 +3344,11 @@
           <a:p>
             <a:pPr>
               <a:spcAft>
-                <a:spcPts val="1400"/>
-              </a:spcAft>
-            </a:pPr>
-            <a:r>
-              <a:rPr sz="2000" b="1">
+                <a:spcPts val="800"/>
+              </a:spcAft>
+            </a:pPr>
+            <a:r>
+              <a:rPr sz="1800" b="1">
                 <a:solidFill>
                   <a:srgbClr val="000000"/>
                 </a:solidFill>
@@ -3358,7 +3357,7 @@
               <a:t>• Team ID- </a:t>
             </a:r>
             <a:r>
-              <a:rPr sz="2000" b="1">
+              <a:rPr sz="1800" b="1">
                 <a:solidFill>
                   <a:srgbClr val="184C94"/>
                 </a:solidFill>
@@ -3370,11 +3369,11 @@
           <a:p>
             <a:pPr>
               <a:spcAft>
-                <a:spcPts val="1400"/>
-              </a:spcAft>
-            </a:pPr>
-            <a:r>
-              <a:rPr sz="2000" b="1">
+                <a:spcPts val="800"/>
+              </a:spcAft>
+            </a:pPr>
+            <a:r>
+              <a:rPr sz="1800" b="1">
                 <a:solidFill>
                   <a:srgbClr val="000000"/>
                 </a:solidFill>
@@ -3383,13 +3382,125 @@
               <a:t>• Team Name- </a:t>
             </a:r>
             <a:r>
-              <a:rPr sz="2000" b="1">
+              <a:rPr sz="1800" b="1">
                 <a:solidFill>
                   <a:srgbClr val="184C94"/>
                 </a:solidFill>
                 <a:latin typeface="Arial"/>
               </a:rPr>
               <a:t>Team Rookie</a:t>
+            </a:r>
+          </a:p>
+          <a:p>
+            <a:pPr>
+              <a:spcAft>
+                <a:spcPts val="800"/>
+              </a:spcAft>
+            </a:pPr>
+            <a:r>
+              <a:rPr sz="1600" b="1">
+                <a:solidFill>
+                  <a:srgbClr val="000000"/>
+                </a:solidFill>
+                <a:latin typeface="Arial"/>
+              </a:rPr>
+              <a:t>• Team Members- </a:t>
+            </a:r>
+            <a:r>
+              <a:rPr sz="1600" b="1">
+                <a:solidFill>
+                  <a:srgbClr val="184C94"/>
+                </a:solidFill>
+                <a:latin typeface="Arial"/>
+              </a:rPr>
+              <a:t>Nikhil Kanse, Shivish Kumar, Tejas Patil, Pranav Pawale, Harsh Narkar, Blessy</a:t>
+            </a:r>
+          </a:p>
+        </p:txBody>
+      </p:sp>
+      <p:sp>
+        <p:nvSpPr>
+          <p:cNvPr id="7" name="Rectangle 6"/>
+          <p:cNvSpPr/>
+          <p:nvPr/>
+        </p:nvSpPr>
+        <p:spPr>
+          <a:xfrm>
+            <a:off x="457200" y="6473952"/>
+            <a:ext cx="11277295" cy="13716"/>
+          </a:xfrm>
+          <a:prstGeom prst="rect">
+            <a:avLst/>
+          </a:prstGeom>
+          <a:solidFill>
+            <a:srgbClr val="E2E8F0"/>
+          </a:solidFill>
+          <a:ln>
+            <a:noFill/>
+          </a:ln>
+        </p:spPr>
+        <p:style>
+          <a:lnRef idx="1">
+            <a:schemeClr val="accent1"/>
+          </a:lnRef>
+          <a:fillRef idx="3">
+            <a:schemeClr val="accent1"/>
+          </a:fillRef>
+          <a:effectRef idx="2">
+            <a:schemeClr val="accent1"/>
+          </a:effectRef>
+          <a:fontRef idx="minor">
+            <a:schemeClr val="lt1"/>
+          </a:fontRef>
+        </p:style>
+        <p:txBody>
+          <a:bodyPr rtlCol="0" anchor="ctr"/>
+          <a:lstStyle/>
+          <a:p>
+            <a:pPr algn="ctr"/>
+          </a:p>
+        </p:txBody>
+      </p:sp>
+      <p:sp>
+        <p:nvSpPr>
+          <p:cNvPr id="8" name="TextBox 7"/>
+          <p:cNvSpPr txBox="1"/>
+          <p:nvPr/>
+        </p:nvSpPr>
+        <p:spPr>
+          <a:xfrm>
+            <a:off x="457200" y="6510528"/>
+            <a:ext cx="11277295" cy="292608"/>
+          </a:xfrm>
+          <a:prstGeom prst="rect">
+            <a:avLst/>
+          </a:prstGeom>
+          <a:noFill/>
+        </p:spPr>
+        <p:txBody>
+          <a:bodyPr wrap="square" lIns="0" rIns="0" tIns="0" bIns="0">
+            <a:spAutoFit/>
+          </a:bodyPr>
+          <a:lstStyle/>
+          <a:p>
+            <a:pPr algn="ctr"/>
+            <a:r>
+              <a:rPr sz="1000" b="1">
+                <a:solidFill>
+                  <a:srgbClr val="475569"/>
+                </a:solidFill>
+                <a:latin typeface="Arial"/>
+              </a:rPr>
+              <a:t>Team Rookie  |  </a:t>
+            </a:r>
+            <a:r>
+              <a:rPr sz="1000" b="1">
+                <a:solidFill>
+                  <a:srgbClr val="1E293B"/>
+                </a:solidFill>
+                <a:latin typeface="Arial"/>
+              </a:rPr>
+              <a:t>[ Nikhil Kanse , Shivish Kumar , Tejas Patil , Pranav Pawale , Harsh Narkar , Blessy ]</a:t>
             </a:r>
           </a:p>
         </p:txBody>
@@ -4285,7 +4396,7 @@
         <p:spPr>
           <a:xfrm>
             <a:off x="8321040" y="3977639"/>
-            <a:ext cx="3566160" cy="2514600"/>
+            <a:ext cx="3566160" cy="2377440"/>
           </a:xfrm>
           <a:prstGeom prst="roundRect">
             <a:avLst/>
@@ -4330,7 +4441,7 @@
         <p:spPr>
           <a:xfrm>
             <a:off x="8458200" y="4069080"/>
-            <a:ext cx="3291840" cy="2331720"/>
+            <a:ext cx="3291840" cy="2194560"/>
           </a:xfrm>
           <a:prstGeom prst="rect">
             <a:avLst/>
@@ -4404,6 +4515,93 @@
             </a:pPr>
             <a:r>
               <a:t>• Equips DGCA with instant surge anomaly alerts to detect regional price gouging.</a:t>
+            </a:r>
+          </a:p>
+        </p:txBody>
+      </p:sp>
+      <p:sp>
+        <p:nvSpPr>
+          <p:cNvPr id="18" name="Rectangle 17"/>
+          <p:cNvSpPr/>
+          <p:nvPr/>
+        </p:nvSpPr>
+        <p:spPr>
+          <a:xfrm>
+            <a:off x="457200" y="6473952"/>
+            <a:ext cx="11277295" cy="13716"/>
+          </a:xfrm>
+          <a:prstGeom prst="rect">
+            <a:avLst/>
+          </a:prstGeom>
+          <a:solidFill>
+            <a:srgbClr val="E2E8F0"/>
+          </a:solidFill>
+          <a:ln>
+            <a:noFill/>
+          </a:ln>
+        </p:spPr>
+        <p:style>
+          <a:lnRef idx="1">
+            <a:schemeClr val="accent1"/>
+          </a:lnRef>
+          <a:fillRef idx="3">
+            <a:schemeClr val="accent1"/>
+          </a:fillRef>
+          <a:effectRef idx="2">
+            <a:schemeClr val="accent1"/>
+          </a:effectRef>
+          <a:fontRef idx="minor">
+            <a:schemeClr val="lt1"/>
+          </a:fontRef>
+        </p:style>
+        <p:txBody>
+          <a:bodyPr rtlCol="0" anchor="ctr"/>
+          <a:lstStyle/>
+          <a:p>
+            <a:pPr algn="ctr"/>
+          </a:p>
+        </p:txBody>
+      </p:sp>
+      <p:sp>
+        <p:nvSpPr>
+          <p:cNvPr id="19" name="TextBox 18"/>
+          <p:cNvSpPr txBox="1"/>
+          <p:nvPr/>
+        </p:nvSpPr>
+        <p:spPr>
+          <a:xfrm>
+            <a:off x="457200" y="6510528"/>
+            <a:ext cx="11277295" cy="292608"/>
+          </a:xfrm>
+          <a:prstGeom prst="rect">
+            <a:avLst/>
+          </a:prstGeom>
+          <a:noFill/>
+        </p:spPr>
+        <p:txBody>
+          <a:bodyPr wrap="square" lIns="0" rIns="0" tIns="0" bIns="0">
+            <a:spAutoFit/>
+          </a:bodyPr>
+          <a:lstStyle/>
+          <a:p>
+            <a:pPr algn="ctr"/>
+            <a:r>
+              <a:rPr sz="1000" b="1">
+                <a:solidFill>
+                  <a:srgbClr val="475569"/>
+                </a:solidFill>
+                <a:latin typeface="Arial"/>
+              </a:rPr>
+              <a:t>Team Rookie  |  </a:t>
+            </a:r>
+            <a:r>
+              <a:rPr sz="1000" b="1">
+                <a:solidFill>
+                  <a:srgbClr val="1E293B"/>
+                </a:solidFill>
+                <a:latin typeface="Arial"/>
+              </a:rPr>
+              <a:t>[ Nikhil Kanse , Shivish Kumar , Tejas Patil , Pranav Pawale , Harsh Narkar , Blessy ]</a:t>
             </a:r>
           </a:p>
         </p:txBody>
@@ -4731,7 +4929,7 @@
         <p:spPr>
           <a:xfrm>
             <a:off x="457200" y="4434840"/>
-            <a:ext cx="6583680" cy="2148840"/>
+            <a:ext cx="6583680" cy="1965960"/>
           </a:xfrm>
           <a:prstGeom prst="rect">
             <a:avLst/>
@@ -4747,7 +4945,7 @@
         <p:spPr>
           <a:xfrm>
             <a:off x="7315200" y="1280160"/>
-            <a:ext cx="4389120" cy="5212080"/>
+            <a:ext cx="4389120" cy="5074920"/>
           </a:xfrm>
           <a:prstGeom prst="roundRect">
             <a:avLst/>
@@ -4791,8 +4989,8 @@
         </p:nvSpPr>
         <p:spPr>
           <a:xfrm>
-            <a:off x="7498079" y="1463040"/>
-            <a:ext cx="4023360" cy="4846320"/>
+            <a:off x="7498079" y="1417320"/>
+            <a:ext cx="4023360" cy="4754880"/>
           </a:xfrm>
           <a:prstGeom prst="rect">
             <a:avLst/>
@@ -4807,7 +5005,7 @@
           <a:p>
             <a:pPr algn="ctr">
               <a:spcAft>
-                <a:spcPts val="1000"/>
+                <a:spcPts val="800"/>
               </a:spcAft>
               <a:defRPr sz="2400" b="1">
                 <a:solidFill>
@@ -4823,9 +5021,9 @@
           <a:p>
             <a:pPr algn="ctr">
               <a:spcAft>
-                <a:spcPts val="400"/>
-              </a:spcAft>
-              <a:defRPr sz="1400" b="1">
+                <a:spcPts val="300"/>
+              </a:spcAft>
+              <a:defRPr sz="1350" b="1">
                 <a:solidFill>
                   <a:srgbClr val="000000"/>
                 </a:solidFill>
@@ -4839,9 +5037,9 @@
           <a:p>
             <a:pPr algn="ctr">
               <a:spcAft>
-                <a:spcPts val="400"/>
-              </a:spcAft>
-              <a:defRPr sz="1400" b="1">
+                <a:spcPts val="300"/>
+              </a:spcAft>
+              <a:defRPr sz="1350" b="1">
                 <a:solidFill>
                   <a:srgbClr val="000000"/>
                 </a:solidFill>
@@ -4855,9 +5053,9 @@
           <a:p>
             <a:pPr algn="ctr">
               <a:spcAft>
-                <a:spcPts val="400"/>
-              </a:spcAft>
-              <a:defRPr sz="1400" b="1">
+                <a:spcPts val="300"/>
+              </a:spcAft>
+              <a:defRPr sz="1350" b="1">
                 <a:solidFill>
                   <a:srgbClr val="000000"/>
                 </a:solidFill>
@@ -4871,9 +5069,9 @@
           <a:p>
             <a:pPr algn="ctr">
               <a:spcAft>
-                <a:spcPts val="400"/>
-              </a:spcAft>
-              <a:defRPr sz="1400" b="1">
+                <a:spcPts val="300"/>
+              </a:spcAft>
+              <a:defRPr sz="1350" b="1">
                 <a:solidFill>
                   <a:srgbClr val="000000"/>
                 </a:solidFill>
@@ -4887,9 +5085,9 @@
           <a:p>
             <a:pPr algn="ctr">
               <a:spcAft>
-                <a:spcPts val="400"/>
-              </a:spcAft>
-              <a:defRPr sz="1400" b="1">
+                <a:spcPts val="300"/>
+              </a:spcAft>
+              <a:defRPr sz="1350" b="1">
                 <a:solidFill>
                   <a:srgbClr val="000000"/>
                 </a:solidFill>
@@ -4903,9 +5101,9 @@
           <a:p>
             <a:pPr algn="ctr">
               <a:spcAft>
-                <a:spcPts val="400"/>
-              </a:spcAft>
-              <a:defRPr sz="1400" b="1">
+                <a:spcPts val="300"/>
+              </a:spcAft>
+              <a:defRPr sz="1350" b="1">
                 <a:solidFill>
                   <a:srgbClr val="000000"/>
                 </a:solidFill>
@@ -4919,9 +5117,9 @@
           <a:p>
             <a:pPr algn="ctr">
               <a:spcAft>
-                <a:spcPts val="400"/>
-              </a:spcAft>
-              <a:defRPr sz="1400" b="1">
+                <a:spcPts val="300"/>
+              </a:spcAft>
+              <a:defRPr sz="1350" b="1">
                 <a:solidFill>
                   <a:srgbClr val="000000"/>
                 </a:solidFill>
@@ -4935,9 +5133,9 @@
           <a:p>
             <a:pPr algn="ctr">
               <a:spcAft>
-                <a:spcPts val="400"/>
-              </a:spcAft>
-              <a:defRPr sz="1400" b="1">
+                <a:spcPts val="300"/>
+              </a:spcAft>
+              <a:defRPr sz="1350" b="1">
                 <a:solidFill>
                   <a:srgbClr val="000000"/>
                 </a:solidFill>
@@ -4951,9 +5149,9 @@
           <a:p>
             <a:pPr algn="ctr">
               <a:spcAft>
-                <a:spcPts val="400"/>
-              </a:spcAft>
-              <a:defRPr sz="1400" b="1">
+                <a:spcPts val="300"/>
+              </a:spcAft>
+              <a:defRPr sz="1350" b="1">
                 <a:solidFill>
                   <a:srgbClr val="000000"/>
                 </a:solidFill>
@@ -4967,9 +5165,9 @@
           <a:p>
             <a:pPr algn="ctr">
               <a:spcAft>
-                <a:spcPts val="400"/>
-              </a:spcAft>
-              <a:defRPr sz="1400" b="1">
+                <a:spcPts val="300"/>
+              </a:spcAft>
+              <a:defRPr sz="1350" b="1">
                 <a:solidFill>
                   <a:srgbClr val="000000"/>
                 </a:solidFill>
@@ -4983,9 +5181,9 @@
           <a:p>
             <a:pPr algn="ctr">
               <a:spcAft>
-                <a:spcPts val="400"/>
-              </a:spcAft>
-              <a:defRPr sz="1400" b="1">
+                <a:spcPts val="300"/>
+              </a:spcAft>
+              <a:defRPr sz="1350" b="1">
                 <a:solidFill>
                   <a:srgbClr val="000000"/>
                 </a:solidFill>
@@ -4999,9 +5197,9 @@
           <a:p>
             <a:pPr algn="ctr">
               <a:spcAft>
-                <a:spcPts val="400"/>
-              </a:spcAft>
-              <a:defRPr sz="1400" b="1">
+                <a:spcPts val="300"/>
+              </a:spcAft>
+              <a:defRPr sz="1350" b="1">
                 <a:solidFill>
                   <a:srgbClr val="000000"/>
                 </a:solidFill>
@@ -5010,6 +5208,93 @@
             </a:pPr>
             <a:r>
               <a:t>• Docker &amp; Vercel Edge</a:t>
+            </a:r>
+          </a:p>
+        </p:txBody>
+      </p:sp>
+      <p:sp>
+        <p:nvSpPr>
+          <p:cNvPr id="12" name="Rectangle 11"/>
+          <p:cNvSpPr/>
+          <p:nvPr/>
+        </p:nvSpPr>
+        <p:spPr>
+          <a:xfrm>
+            <a:off x="457200" y="6473952"/>
+            <a:ext cx="11277295" cy="13716"/>
+          </a:xfrm>
+          <a:prstGeom prst="rect">
+            <a:avLst/>
+          </a:prstGeom>
+          <a:solidFill>
+            <a:srgbClr val="E2E8F0"/>
+          </a:solidFill>
+          <a:ln>
+            <a:noFill/>
+          </a:ln>
+        </p:spPr>
+        <p:style>
+          <a:lnRef idx="1">
+            <a:schemeClr val="accent1"/>
+          </a:lnRef>
+          <a:fillRef idx="3">
+            <a:schemeClr val="accent1"/>
+          </a:fillRef>
+          <a:effectRef idx="2">
+            <a:schemeClr val="accent1"/>
+          </a:effectRef>
+          <a:fontRef idx="minor">
+            <a:schemeClr val="lt1"/>
+          </a:fontRef>
+        </p:style>
+        <p:txBody>
+          <a:bodyPr rtlCol="0" anchor="ctr"/>
+          <a:lstStyle/>
+          <a:p>
+            <a:pPr algn="ctr"/>
+          </a:p>
+        </p:txBody>
+      </p:sp>
+      <p:sp>
+        <p:nvSpPr>
+          <p:cNvPr id="13" name="TextBox 12"/>
+          <p:cNvSpPr txBox="1"/>
+          <p:nvPr/>
+        </p:nvSpPr>
+        <p:spPr>
+          <a:xfrm>
+            <a:off x="457200" y="6510528"/>
+            <a:ext cx="11277295" cy="292608"/>
+          </a:xfrm>
+          <a:prstGeom prst="rect">
+            <a:avLst/>
+          </a:prstGeom>
+          <a:noFill/>
+        </p:spPr>
+        <p:txBody>
+          <a:bodyPr wrap="square" lIns="0" rIns="0" tIns="0" bIns="0">
+            <a:spAutoFit/>
+          </a:bodyPr>
+          <a:lstStyle/>
+          <a:p>
+            <a:pPr algn="ctr"/>
+            <a:r>
+              <a:rPr sz="1000" b="1">
+                <a:solidFill>
+                  <a:srgbClr val="475569"/>
+                </a:solidFill>
+                <a:latin typeface="Arial"/>
+              </a:rPr>
+              <a:t>Team Rookie  |  </a:t>
+            </a:r>
+            <a:r>
+              <a:rPr sz="1000" b="1">
+                <a:solidFill>
+                  <a:srgbClr val="1E293B"/>
+                </a:solidFill>
+                <a:latin typeface="Arial"/>
+              </a:rPr>
+              <a:t>[ Nikhil Kanse , Shivish Kumar , Tejas Patil , Pranav Pawale , Harsh Narkar , Blessy ]</a:t>
             </a:r>
           </a:p>
         </p:txBody>
@@ -5864,6 +6149,93 @@
           </a:p>
         </p:txBody>
       </p:sp>
+      <p:sp>
+        <p:nvSpPr>
+          <p:cNvPr id="15" name="Rectangle 14"/>
+          <p:cNvSpPr/>
+          <p:nvPr/>
+        </p:nvSpPr>
+        <p:spPr>
+          <a:xfrm>
+            <a:off x="457200" y="6473952"/>
+            <a:ext cx="11277295" cy="13716"/>
+          </a:xfrm>
+          <a:prstGeom prst="rect">
+            <a:avLst/>
+          </a:prstGeom>
+          <a:solidFill>
+            <a:srgbClr val="E2E8F0"/>
+          </a:solidFill>
+          <a:ln>
+            <a:noFill/>
+          </a:ln>
+        </p:spPr>
+        <p:style>
+          <a:lnRef idx="1">
+            <a:schemeClr val="accent1"/>
+          </a:lnRef>
+          <a:fillRef idx="3">
+            <a:schemeClr val="accent1"/>
+          </a:fillRef>
+          <a:effectRef idx="2">
+            <a:schemeClr val="accent1"/>
+          </a:effectRef>
+          <a:fontRef idx="minor">
+            <a:schemeClr val="lt1"/>
+          </a:fontRef>
+        </p:style>
+        <p:txBody>
+          <a:bodyPr rtlCol="0" anchor="ctr"/>
+          <a:lstStyle/>
+          <a:p>
+            <a:pPr algn="ctr"/>
+          </a:p>
+        </p:txBody>
+      </p:sp>
+      <p:sp>
+        <p:nvSpPr>
+          <p:cNvPr id="16" name="TextBox 15"/>
+          <p:cNvSpPr txBox="1"/>
+          <p:nvPr/>
+        </p:nvSpPr>
+        <p:spPr>
+          <a:xfrm>
+            <a:off x="457200" y="6510528"/>
+            <a:ext cx="11277295" cy="292608"/>
+          </a:xfrm>
+          <a:prstGeom prst="rect">
+            <a:avLst/>
+          </a:prstGeom>
+          <a:noFill/>
+        </p:spPr>
+        <p:txBody>
+          <a:bodyPr wrap="square" lIns="0" rIns="0" tIns="0" bIns="0">
+            <a:spAutoFit/>
+          </a:bodyPr>
+          <a:lstStyle/>
+          <a:p>
+            <a:pPr algn="ctr"/>
+            <a:r>
+              <a:rPr sz="1000" b="1">
+                <a:solidFill>
+                  <a:srgbClr val="475569"/>
+                </a:solidFill>
+                <a:latin typeface="Arial"/>
+              </a:rPr>
+              <a:t>Team Rookie  |  </a:t>
+            </a:r>
+            <a:r>
+              <a:rPr sz="1000" b="1">
+                <a:solidFill>
+                  <a:srgbClr val="1E293B"/>
+                </a:solidFill>
+                <a:latin typeface="Arial"/>
+              </a:rPr>
+              <a:t>[ Nikhil Kanse , Shivish Kumar , Tejas Patil , Pranav Pawale , Harsh Narkar , Blessy ]</a:t>
+            </a:r>
+          </a:p>
+        </p:txBody>
+      </p:sp>
     </p:spTree>
   </p:cSld>
   <p:clrMapOvr>
@@ -6555,7 +6927,7 @@
           <a:p>
             <a:pPr>
               <a:spcAft>
-                <a:spcPts val="1200"/>
+                <a:spcPts val="1000"/>
               </a:spcAft>
             </a:pPr>
             <a:r>
@@ -6580,7 +6952,7 @@
           <a:p>
             <a:pPr>
               <a:spcAft>
-                <a:spcPts val="1200"/>
+                <a:spcPts val="1000"/>
               </a:spcAft>
             </a:pPr>
             <a:r>
@@ -6605,7 +6977,7 @@
           <a:p>
             <a:pPr>
               <a:spcAft>
-                <a:spcPts val="1200"/>
+                <a:spcPts val="1000"/>
               </a:spcAft>
             </a:pPr>
             <a:r>
@@ -6630,7 +7002,7 @@
           <a:p>
             <a:pPr>
               <a:spcAft>
-                <a:spcPts val="1200"/>
+                <a:spcPts val="1000"/>
               </a:spcAft>
             </a:pPr>
             <a:r>
@@ -6655,7 +7027,7 @@
           <a:p>
             <a:pPr>
               <a:spcAft>
-                <a:spcPts val="1200"/>
+                <a:spcPts val="1000"/>
               </a:spcAft>
             </a:pPr>
             <a:r>
@@ -6675,6 +7047,93 @@
                 <a:latin typeface="Arial"/>
               </a:rPr>
               <a:t>Deploy LLM agents to draft automated weekly inflation briefs and alert DGCA of pricing anomalies.</a:t>
+            </a:r>
+          </a:p>
+        </p:txBody>
+      </p:sp>
+      <p:sp>
+        <p:nvSpPr>
+          <p:cNvPr id="16" name="Rectangle 15"/>
+          <p:cNvSpPr/>
+          <p:nvPr/>
+        </p:nvSpPr>
+        <p:spPr>
+          <a:xfrm>
+            <a:off x="457200" y="6473952"/>
+            <a:ext cx="11277295" cy="13716"/>
+          </a:xfrm>
+          <a:prstGeom prst="rect">
+            <a:avLst/>
+          </a:prstGeom>
+          <a:solidFill>
+            <a:srgbClr val="E2E8F0"/>
+          </a:solidFill>
+          <a:ln>
+            <a:noFill/>
+          </a:ln>
+        </p:spPr>
+        <p:style>
+          <a:lnRef idx="1">
+            <a:schemeClr val="accent1"/>
+          </a:lnRef>
+          <a:fillRef idx="3">
+            <a:schemeClr val="accent1"/>
+          </a:fillRef>
+          <a:effectRef idx="2">
+            <a:schemeClr val="accent1"/>
+          </a:effectRef>
+          <a:fontRef idx="minor">
+            <a:schemeClr val="lt1"/>
+          </a:fontRef>
+        </p:style>
+        <p:txBody>
+          <a:bodyPr rtlCol="0" anchor="ctr"/>
+          <a:lstStyle/>
+          <a:p>
+            <a:pPr algn="ctr"/>
+          </a:p>
+        </p:txBody>
+      </p:sp>
+      <p:sp>
+        <p:nvSpPr>
+          <p:cNvPr id="17" name="TextBox 16"/>
+          <p:cNvSpPr txBox="1"/>
+          <p:nvPr/>
+        </p:nvSpPr>
+        <p:spPr>
+          <a:xfrm>
+            <a:off x="457200" y="6510528"/>
+            <a:ext cx="11277295" cy="292608"/>
+          </a:xfrm>
+          <a:prstGeom prst="rect">
+            <a:avLst/>
+          </a:prstGeom>
+          <a:noFill/>
+        </p:spPr>
+        <p:txBody>
+          <a:bodyPr wrap="square" lIns="0" rIns="0" tIns="0" bIns="0">
+            <a:spAutoFit/>
+          </a:bodyPr>
+          <a:lstStyle/>
+          <a:p>
+            <a:pPr algn="ctr"/>
+            <a:r>
+              <a:rPr sz="1000" b="1">
+                <a:solidFill>
+                  <a:srgbClr val="475569"/>
+                </a:solidFill>
+                <a:latin typeface="Arial"/>
+              </a:rPr>
+              <a:t>Team Rookie  |  </a:t>
+            </a:r>
+            <a:r>
+              <a:rPr sz="1000" b="1">
+                <a:solidFill>
+                  <a:srgbClr val="1E293B"/>
+                </a:solidFill>
+                <a:latin typeface="Arial"/>
+              </a:rPr>
+              <a:t>[ Nikhil Kanse , Shivish Kumar , Tejas Patil , Pranav Pawale , Harsh Narkar , Blessy ]</a:t>
             </a:r>
           </a:p>
         </p:txBody>
@@ -6742,351 +7201,6 @@
       </p:sp>
       <p:sp>
         <p:nvSpPr>
-          <p:cNvPr id="3" name="Oval 2"/>
-          <p:cNvSpPr/>
-          <p:nvPr/>
-        </p:nvSpPr>
-        <p:spPr>
-          <a:xfrm>
-            <a:off x="365760" y="228600"/>
-            <a:ext cx="1645920" cy="777240"/>
-          </a:xfrm>
-          <a:prstGeom prst="ellipse">
-            <a:avLst/>
-          </a:prstGeom>
-          <a:solidFill>
-            <a:srgbClr val="FFFFFF"/>
-          </a:solidFill>
-          <a:ln w="25400">
-            <a:solidFill>
-              <a:srgbClr val="64508C"/>
-            </a:solidFill>
-          </a:ln>
-        </p:spPr>
-        <p:style>
-          <a:lnRef idx="1">
-            <a:schemeClr val="accent1"/>
-          </a:lnRef>
-          <a:fillRef idx="3">
-            <a:schemeClr val="accent1"/>
-          </a:fillRef>
-          <a:effectRef idx="2">
-            <a:schemeClr val="accent1"/>
-          </a:effectRef>
-          <a:fontRef idx="minor">
-            <a:schemeClr val="lt1"/>
-          </a:fontRef>
-        </p:style>
-        <p:txBody>
-          <a:bodyPr rtlCol="0" anchor="ctr" wrap="square"/>
-          <a:lstStyle/>
-          <a:p>
-            <a:pPr algn="ctr">
-              <a:defRPr sz="1400" b="1">
-                <a:solidFill>
-                  <a:srgbClr val="000000"/>
-                </a:solidFill>
-                <a:latin typeface="Arial"/>
-              </a:defRPr>
-            </a:pPr>
-            <a:r>
-              <a:t>Team Rookie</a:t>
-            </a:r>
-          </a:p>
-        </p:txBody>
-      </p:sp>
-      <p:sp>
-        <p:nvSpPr>
-          <p:cNvPr id="4" name="TextBox 3"/>
-          <p:cNvSpPr txBox="1"/>
-          <p:nvPr/>
-        </p:nvSpPr>
-        <p:spPr>
-          <a:xfrm>
-            <a:off x="2286000" y="182880"/>
-            <a:ext cx="7589520" cy="914400"/>
-          </a:xfrm>
-          <a:prstGeom prst="rect">
-            <a:avLst/>
-          </a:prstGeom>
-          <a:noFill/>
-        </p:spPr>
-        <p:txBody>
-          <a:bodyPr wrap="square" lIns="0" rIns="0" tIns="0" bIns="0">
-            <a:spAutoFit/>
-          </a:bodyPr>
-          <a:lstStyle/>
-          <a:p>
-            <a:pPr algn="ctr">
-              <a:defRPr sz="2800" b="1">
-                <a:solidFill>
-                  <a:srgbClr val="1B365D"/>
-                </a:solidFill>
-                <a:latin typeface="Times New Roman"/>
-              </a:defRPr>
-            </a:pPr>
-            <a:r>
-              <a:t>DEMO/PROTOTYPE</a:t>
-            </a:r>
-          </a:p>
-        </p:txBody>
-      </p:sp>
-      <p:pic>
-        <p:nvPicPr>
-          <p:cNvPr id="5" name="Picture 4" descr="sih_2026_logo_hd.png"/>
-          <p:cNvPicPr>
-            <a:picLocks noChangeAspect="1"/>
-          </p:cNvPicPr>
-          <p:nvPr/>
-        </p:nvPicPr>
-        <p:blipFill>
-          <a:blip r:embed="rId2"/>
-          <a:stretch>
-            <a:fillRect/>
-          </a:stretch>
-        </p:blipFill>
-        <p:spPr>
-          <a:xfrm>
-            <a:off x="10058400" y="146304"/>
-            <a:ext cx="1828800" cy="914400"/>
-          </a:xfrm>
-          <a:prstGeom prst="rect">
-            <a:avLst/>
-          </a:prstGeom>
-        </p:spPr>
-      </p:pic>
-      <p:sp>
-        <p:nvSpPr>
-          <p:cNvPr id="6" name="TextBox 5"/>
-          <p:cNvSpPr txBox="1"/>
-          <p:nvPr/>
-        </p:nvSpPr>
-        <p:spPr>
-          <a:xfrm>
-            <a:off x="914400" y="1188720"/>
-            <a:ext cx="4572000" cy="365760"/>
-          </a:xfrm>
-          <a:prstGeom prst="rect">
-            <a:avLst/>
-          </a:prstGeom>
-          <a:noFill/>
-        </p:spPr>
-        <p:txBody>
-          <a:bodyPr wrap="none">
-            <a:spAutoFit/>
-          </a:bodyPr>
-          <a:lstStyle/>
-          <a:p>
-            <a:pPr algn="ctr">
-              <a:defRPr sz="2200" b="1">
-                <a:solidFill>
-                  <a:srgbClr val="000000"/>
-                </a:solidFill>
-                <a:latin typeface="Arial"/>
-              </a:defRPr>
-            </a:pPr>
-            <a:r>
-              <a:t>DEMO</a:t>
-            </a:r>
-          </a:p>
-        </p:txBody>
-      </p:sp>
-      <p:sp>
-        <p:nvSpPr>
-          <p:cNvPr id="7" name="TextBox 6"/>
-          <p:cNvSpPr txBox="1"/>
-          <p:nvPr/>
-        </p:nvSpPr>
-        <p:spPr>
-          <a:xfrm>
-            <a:off x="6583680" y="1188720"/>
-            <a:ext cx="4572000" cy="365760"/>
-          </a:xfrm>
-          <a:prstGeom prst="rect">
-            <a:avLst/>
-          </a:prstGeom>
-          <a:noFill/>
-        </p:spPr>
-        <p:txBody>
-          <a:bodyPr wrap="none">
-            <a:spAutoFit/>
-          </a:bodyPr>
-          <a:lstStyle/>
-          <a:p>
-            <a:pPr algn="ctr">
-              <a:defRPr sz="2200" b="1">
-                <a:solidFill>
-                  <a:srgbClr val="000000"/>
-                </a:solidFill>
-                <a:latin typeface="Arial"/>
-              </a:defRPr>
-            </a:pPr>
-            <a:r>
-              <a:t>RESULT</a:t>
-            </a:r>
-          </a:p>
-        </p:txBody>
-      </p:sp>
-      <p:pic>
-        <p:nvPicPr>
-          <p:cNvPr id="8" name="Picture 7" descr="demo_chart_hd.png"/>
-          <p:cNvPicPr>
-            <a:picLocks noChangeAspect="1"/>
-          </p:cNvPicPr>
-          <p:nvPr/>
-        </p:nvPicPr>
-        <p:blipFill>
-          <a:blip r:embed="rId3"/>
-          <a:stretch>
-            <a:fillRect/>
-          </a:stretch>
-        </p:blipFill>
-        <p:spPr>
-          <a:xfrm>
-            <a:off x="548640" y="1600200"/>
-            <a:ext cx="5394960" cy="3154680"/>
-          </a:xfrm>
-          <a:prstGeom prst="rect">
-            <a:avLst/>
-          </a:prstGeom>
-        </p:spPr>
-      </p:pic>
-      <p:pic>
-        <p:nvPicPr>
-          <p:cNvPr id="9" name="Picture 8" descr="demo_table_hd.png"/>
-          <p:cNvPicPr>
-            <a:picLocks noChangeAspect="1"/>
-          </p:cNvPicPr>
-          <p:nvPr/>
-        </p:nvPicPr>
-        <p:blipFill>
-          <a:blip r:embed="rId4"/>
-          <a:stretch>
-            <a:fillRect/>
-          </a:stretch>
-        </p:blipFill>
-        <p:spPr>
-          <a:xfrm>
-            <a:off x="6217920" y="1600200"/>
-            <a:ext cx="5394960" cy="3154680"/>
-          </a:xfrm>
-          <a:prstGeom prst="rect">
-            <a:avLst/>
-          </a:prstGeom>
-        </p:spPr>
-      </p:pic>
-      <p:sp>
-        <p:nvSpPr>
-          <p:cNvPr id="10" name="TextBox 9"/>
-          <p:cNvSpPr txBox="1"/>
-          <p:nvPr/>
-        </p:nvSpPr>
-        <p:spPr>
-          <a:xfrm>
-            <a:off x="457200" y="4983480"/>
-            <a:ext cx="11277295" cy="1371600"/>
-          </a:xfrm>
-          <a:prstGeom prst="rect">
-            <a:avLst/>
-          </a:prstGeom>
-          <a:noFill/>
-        </p:spPr>
-        <p:txBody>
-          <a:bodyPr wrap="square">
-            <a:spAutoFit/>
-          </a:bodyPr>
-          <a:lstStyle/>
-          <a:p>
-            <a:pPr algn="ctr">
-              <a:defRPr sz="1600" b="1">
-                <a:solidFill>
-                  <a:srgbClr val="000000"/>
-                </a:solidFill>
-                <a:latin typeface="Arial"/>
-              </a:defRPr>
-            </a:pPr>
-            <a:r>
-              <a:t>Here’s the link to AirIntel India — your gateway to real-time airfare CPI intelligence:</a:t>
-            </a:r>
-          </a:p>
-          <a:p>
-            <a:pPr algn="ctr">
-              <a:defRPr sz="2200" b="1" u="sng">
-                <a:solidFill>
-                  <a:srgbClr val="1D4ED8"/>
-                </a:solidFill>
-                <a:latin typeface="Arial"/>
-              </a:defRPr>
-            </a:pPr>
-            <a:r>
-              <a:t>https://sihwinners.vercel.app</a:t>
-            </a:r>
-          </a:p>
-        </p:txBody>
-      </p:sp>
-    </p:spTree>
-  </p:cSld>
-  <p:clrMapOvr>
-    <a:masterClrMapping/>
-  </p:clrMapOvr>
-</p:sld>
-</file>
-
-<file path=ppt/slides/slide7.xml><?xml version="1.0" encoding="utf-8"?>
-<p:sld xmlns:a="http://schemas.openxmlformats.org/drawingml/2006/main" xmlns:p="http://schemas.openxmlformats.org/presentationml/2006/main" xmlns:r="http://schemas.openxmlformats.org/officeDocument/2006/relationships">
-  <p:cSld>
-    <p:spTree>
-      <p:nvGrpSpPr>
-        <p:cNvPr id="1" name=""/>
-        <p:cNvGrpSpPr/>
-        <p:nvPr/>
-      </p:nvGrpSpPr>
-      <p:grpSpPr/>
-      <p:sp>
-        <p:nvSpPr>
-          <p:cNvPr id="2" name="Rectangle 1"/>
-          <p:cNvSpPr/>
-          <p:nvPr/>
-        </p:nvSpPr>
-        <p:spPr>
-          <a:xfrm>
-            <a:off x="0" y="0"/>
-            <a:ext cx="12191695" cy="6858000"/>
-          </a:xfrm>
-          <a:prstGeom prst="rect">
-            <a:avLst/>
-          </a:prstGeom>
-          <a:solidFill>
-            <a:srgbClr val="FFFFFF"/>
-          </a:solidFill>
-          <a:ln>
-            <a:noFill/>
-          </a:ln>
-        </p:spPr>
-        <p:style>
-          <a:lnRef idx="1">
-            <a:schemeClr val="accent1"/>
-          </a:lnRef>
-          <a:fillRef idx="3">
-            <a:schemeClr val="accent1"/>
-          </a:fillRef>
-          <a:effectRef idx="2">
-            <a:schemeClr val="accent1"/>
-          </a:effectRef>
-          <a:fontRef idx="minor">
-            <a:schemeClr val="lt1"/>
-          </a:fontRef>
-        </p:style>
-        <p:txBody>
-          <a:bodyPr rtlCol="0" anchor="ctr"/>
-          <a:lstStyle/>
-          <a:p>
-            <a:pPr algn="ctr"/>
-          </a:p>
-        </p:txBody>
-      </p:sp>
-      <p:sp>
-        <p:nvSpPr>
           <p:cNvPr id="3" name="TextBox 2"/>
           <p:cNvSpPr txBox="1"/>
           <p:nvPr/>
@@ -7154,7 +7268,7 @@
         <p:spPr>
           <a:xfrm>
             <a:off x="320040" y="1234440"/>
-            <a:ext cx="5715000" cy="2560320"/>
+            <a:ext cx="5715000" cy="2423160"/>
           </a:xfrm>
           <a:prstGeom prst="rect">
             <a:avLst/>
@@ -7197,7 +7311,7 @@
         <p:spPr>
           <a:xfrm>
             <a:off x="548640" y="1417320"/>
-            <a:ext cx="5257800" cy="2286000"/>
+            <a:ext cx="5257800" cy="2148840"/>
           </a:xfrm>
           <a:prstGeom prst="rect">
             <a:avLst/>
@@ -7268,7 +7382,7 @@
         <p:spPr>
           <a:xfrm>
             <a:off x="6172200" y="1234440"/>
-            <a:ext cx="5715000" cy="2560320"/>
+            <a:ext cx="5715000" cy="2423160"/>
           </a:xfrm>
           <a:prstGeom prst="rect">
             <a:avLst/>
@@ -7311,7 +7425,7 @@
         <p:spPr>
           <a:xfrm>
             <a:off x="6400800" y="1417320"/>
-            <a:ext cx="5257800" cy="2286000"/>
+            <a:ext cx="5257800" cy="2148840"/>
           </a:xfrm>
           <a:prstGeom prst="rect">
             <a:avLst/>
@@ -7413,8 +7527,8 @@
         </p:nvSpPr>
         <p:spPr>
           <a:xfrm>
-            <a:off x="320040" y="3977639"/>
-            <a:ext cx="5715000" cy="2560320"/>
+            <a:off x="320040" y="3886200"/>
+            <a:ext cx="5715000" cy="2423160"/>
           </a:xfrm>
           <a:prstGeom prst="rect">
             <a:avLst/>
@@ -7456,8 +7570,8 @@
         </p:nvSpPr>
         <p:spPr>
           <a:xfrm>
-            <a:off x="548640" y="4160519"/>
-            <a:ext cx="5257800" cy="2286000"/>
+            <a:off x="548640" y="4069080"/>
+            <a:ext cx="5257800" cy="2148840"/>
           </a:xfrm>
           <a:prstGeom prst="rect">
             <a:avLst/>
@@ -7559,8 +7673,8 @@
         </p:nvSpPr>
         <p:spPr>
           <a:xfrm>
-            <a:off x="6172200" y="3977639"/>
-            <a:ext cx="5715000" cy="2560320"/>
+            <a:off x="6172200" y="3886200"/>
+            <a:ext cx="5715000" cy="2423160"/>
           </a:xfrm>
           <a:prstGeom prst="rect">
             <a:avLst/>
@@ -7602,8 +7716,8 @@
         </p:nvSpPr>
         <p:spPr>
           <a:xfrm>
-            <a:off x="6400800" y="4160519"/>
-            <a:ext cx="5257800" cy="2286000"/>
+            <a:off x="6400800" y="4069080"/>
+            <a:ext cx="5257800" cy="2148840"/>
           </a:xfrm>
           <a:prstGeom prst="rect">
             <a:avLst/>
@@ -7693,6 +7807,93 @@
             </a:pPr>
             <a:r>
               <a:t>• Deployment: Dockerized serverless cron (02:00 AM) + Vercel Edge Web Portal.</a:t>
+            </a:r>
+          </a:p>
+        </p:txBody>
+      </p:sp>
+      <p:sp>
+        <p:nvSpPr>
+          <p:cNvPr id="13" name="Rectangle 12"/>
+          <p:cNvSpPr/>
+          <p:nvPr/>
+        </p:nvSpPr>
+        <p:spPr>
+          <a:xfrm>
+            <a:off x="457200" y="6473952"/>
+            <a:ext cx="11277295" cy="13716"/>
+          </a:xfrm>
+          <a:prstGeom prst="rect">
+            <a:avLst/>
+          </a:prstGeom>
+          <a:solidFill>
+            <a:srgbClr val="E2E8F0"/>
+          </a:solidFill>
+          <a:ln>
+            <a:noFill/>
+          </a:ln>
+        </p:spPr>
+        <p:style>
+          <a:lnRef idx="1">
+            <a:schemeClr val="accent1"/>
+          </a:lnRef>
+          <a:fillRef idx="3">
+            <a:schemeClr val="accent1"/>
+          </a:fillRef>
+          <a:effectRef idx="2">
+            <a:schemeClr val="accent1"/>
+          </a:effectRef>
+          <a:fontRef idx="minor">
+            <a:schemeClr val="lt1"/>
+          </a:fontRef>
+        </p:style>
+        <p:txBody>
+          <a:bodyPr rtlCol="0" anchor="ctr"/>
+          <a:lstStyle/>
+          <a:p>
+            <a:pPr algn="ctr"/>
+          </a:p>
+        </p:txBody>
+      </p:sp>
+      <p:sp>
+        <p:nvSpPr>
+          <p:cNvPr id="14" name="TextBox 13"/>
+          <p:cNvSpPr txBox="1"/>
+          <p:nvPr/>
+        </p:nvSpPr>
+        <p:spPr>
+          <a:xfrm>
+            <a:off x="457200" y="6510528"/>
+            <a:ext cx="11277295" cy="292608"/>
+          </a:xfrm>
+          <a:prstGeom prst="rect">
+            <a:avLst/>
+          </a:prstGeom>
+          <a:noFill/>
+        </p:spPr>
+        <p:txBody>
+          <a:bodyPr wrap="square" lIns="0" rIns="0" tIns="0" bIns="0">
+            <a:spAutoFit/>
+          </a:bodyPr>
+          <a:lstStyle/>
+          <a:p>
+            <a:pPr algn="ctr"/>
+            <a:r>
+              <a:rPr sz="1000" b="1">
+                <a:solidFill>
+                  <a:srgbClr val="475569"/>
+                </a:solidFill>
+                <a:latin typeface="Arial"/>
+              </a:rPr>
+              <a:t>Team Rookie  |  </a:t>
+            </a:r>
+            <a:r>
+              <a:rPr sz="1000" b="1">
+                <a:solidFill>
+                  <a:srgbClr val="1E293B"/>
+                </a:solidFill>
+                <a:latin typeface="Arial"/>
+              </a:rPr>
+              <a:t>[ Nikhil Kanse , Shivish Kumar , Tejas Patil , Pranav Pawale , Harsh Narkar , Blessy ]</a:t>
             </a:r>
           </a:p>
         </p:txBody>

</xml_diff>

<commit_message>
feat(presentation): make Title Page font color uniform and adjust SIH bulb logo alignment
</commit_message>
<xml_diff>
--- a/AirIntel_India_SIH26056_Presentation.pptx
+++ b/AirIntel_India_SIH26056_Presentation.pptx
@@ -3225,8 +3225,8 @@
         </p:blipFill>
         <p:spPr>
           <a:xfrm>
-            <a:off x="6949440" y="1188720"/>
-            <a:ext cx="4389120" cy="5303520"/>
+            <a:off x="7635240" y="1280160"/>
+            <a:ext cx="4023360" cy="4937760"/>
           </a:xfrm>
           <a:prstGeom prst="rect">
             <a:avLst/>
@@ -3241,8 +3241,8 @@
         </p:nvSpPr>
         <p:spPr>
           <a:xfrm>
-            <a:off x="594360" y="1280160"/>
-            <a:ext cx="6858000" cy="5212080"/>
+            <a:off x="594360" y="1325880"/>
+            <a:ext cx="6812280" cy="5120640"/>
           </a:xfrm>
           <a:prstGeom prst="rect">
             <a:avLst/>
@@ -3264,7 +3264,7 @@
               </a:spcAft>
             </a:pPr>
             <a:r>
-              <a:rPr sz="1550" b="1">
+              <a:rPr sz="1500" b="1">
                 <a:solidFill>
                   <a:srgbClr val="000000"/>
                 </a:solidFill>
@@ -3273,7 +3273,7 @@
               <a:t>• Problem Statement ID – </a:t>
             </a:r>
             <a:r>
-              <a:rPr sz="1550" b="1">
+              <a:rPr sz="1500" b="1">
                 <a:solidFill>
                   <a:srgbClr val="000000"/>
                 </a:solidFill>
@@ -3292,7 +3292,7 @@
               </a:spcAft>
             </a:pPr>
             <a:r>
-              <a:rPr sz="1550" b="1">
+              <a:rPr sz="1500" b="1">
                 <a:solidFill>
                   <a:srgbClr val="000000"/>
                 </a:solidFill>
@@ -3301,9 +3301,9 @@
               <a:t>• Problem Statement Title- </a:t>
             </a:r>
             <a:r>
-              <a:rPr sz="1550" b="1">
-                <a:solidFill>
-                  <a:srgbClr val="DC2626"/>
+              <a:rPr sz="1500" b="1">
+                <a:solidFill>
+                  <a:srgbClr val="000000"/>
                 </a:solidFill>
                 <a:latin typeface="Arial"/>
               </a:rPr>
@@ -3320,7 +3320,7 @@
               </a:spcAft>
             </a:pPr>
             <a:r>
-              <a:rPr sz="1550" b="1">
+              <a:rPr sz="1500" b="1">
                 <a:solidFill>
                   <a:srgbClr val="000000"/>
                 </a:solidFill>
@@ -3329,7 +3329,7 @@
               <a:t>• Department – </a:t>
             </a:r>
             <a:r>
-              <a:rPr sz="1550" b="1">
+              <a:rPr sz="1500" b="1">
                 <a:solidFill>
                   <a:srgbClr val="000000"/>
                 </a:solidFill>
@@ -3348,7 +3348,7 @@
               </a:spcAft>
             </a:pPr>
             <a:r>
-              <a:rPr sz="1550" b="1">
+              <a:rPr sz="1500" b="1">
                 <a:solidFill>
                   <a:srgbClr val="000000"/>
                 </a:solidFill>
@@ -3357,7 +3357,7 @@
               <a:t>• Category – </a:t>
             </a:r>
             <a:r>
-              <a:rPr sz="1550" b="1">
+              <a:rPr sz="1500" b="1">
                 <a:solidFill>
                   <a:srgbClr val="000000"/>
                 </a:solidFill>
@@ -3376,7 +3376,7 @@
               </a:spcAft>
             </a:pPr>
             <a:r>
-              <a:rPr sz="1550" b="1">
+              <a:rPr sz="1500" b="1">
                 <a:solidFill>
                   <a:srgbClr val="000000"/>
                 </a:solidFill>
@@ -3385,7 +3385,7 @@
               <a:t>• Theme – </a:t>
             </a:r>
             <a:r>
-              <a:rPr sz="1550" b="1">
+              <a:rPr sz="1500" b="1">
                 <a:solidFill>
                   <a:srgbClr val="000000"/>
                 </a:solidFill>
@@ -3404,7 +3404,7 @@
               </a:spcAft>
             </a:pPr>
             <a:r>
-              <a:rPr sz="1550" b="1">
+              <a:rPr sz="1500" b="1">
                 <a:solidFill>
                   <a:srgbClr val="000000"/>
                 </a:solidFill>
@@ -3413,7 +3413,7 @@
               <a:t>• Team ID – </a:t>
             </a:r>
             <a:r>
-              <a:rPr sz="1550" b="1">
+              <a:rPr sz="1500" b="1">
                 <a:solidFill>
                   <a:srgbClr val="000000"/>
                 </a:solidFill>
@@ -3432,7 +3432,7 @@
               </a:spcAft>
             </a:pPr>
             <a:r>
-              <a:rPr sz="1550" b="1">
+              <a:rPr sz="1500" b="1">
                 <a:solidFill>
                   <a:srgbClr val="000000"/>
                 </a:solidFill>
@@ -3441,7 +3441,7 @@
               <a:t>• Team Name – </a:t>
             </a:r>
             <a:r>
-              <a:rPr sz="1550" b="1">
+              <a:rPr sz="1500" b="1">
                 <a:solidFill>
                   <a:srgbClr val="000000"/>
                 </a:solidFill>

</xml_diff>

<commit_message>
feat(presentation): redesign Slide 2 with professional engineering process cards replacing AI-style circles
</commit_message>
<xml_diff>
--- a/AirIntel_India_SIH26056_Presentation.pptx
+++ b/AirIntel_India_SIH26056_Presentation.pptx
@@ -3651,8 +3651,8 @@
         </p:nvSpPr>
         <p:spPr>
           <a:xfrm>
-            <a:off x="502920" y="1005840"/>
-            <a:ext cx="11155680" cy="365760"/>
+            <a:off x="502920" y="969264"/>
+            <a:ext cx="11155680" cy="320040"/>
           </a:xfrm>
           <a:prstGeom prst="rect">
             <a:avLst/>
@@ -3666,7 +3666,7 @@
           <a:lstStyle/>
           <a:p>
             <a:pPr>
-              <a:defRPr sz="1550" b="1">
+              <a:defRPr sz="1500" b="1">
                 <a:solidFill>
                   <a:srgbClr val="1E40AF"/>
                 </a:solidFill>
@@ -3688,7 +3688,7 @@
         <p:spPr>
           <a:xfrm>
             <a:off x="502920" y="1298448"/>
-            <a:ext cx="5440680" cy="2697480"/>
+            <a:ext cx="5468112" cy="2487168"/>
           </a:xfrm>
           <a:prstGeom prst="roundRect">
             <a:avLst>
@@ -3696,7 +3696,7 @@
             </a:avLst>
           </a:prstGeom>
           <a:solidFill>
-            <a:srgbClr val="F8FAFC"/>
+            <a:srgbClr val="FEF2F2"/>
           </a:solidFill>
           <a:ln w="19050">
             <a:solidFill>
@@ -3735,15 +3735,15 @@
         <p:spPr>
           <a:xfrm>
             <a:off x="502920" y="1298448"/>
-            <a:ext cx="5440680" cy="384048"/>
+            <a:ext cx="5468112" cy="384048"/>
           </a:xfrm>
           <a:prstGeom prst="roundRect">
             <a:avLst>
-              <a:gd name="adj" fmla="val 20000"/>
+              <a:gd name="adj" fmla="val 18000"/>
             </a:avLst>
           </a:prstGeom>
           <a:solidFill>
-            <a:srgbClr val="DC2626"/>
+            <a:srgbClr val="B91C1C"/>
           </a:solidFill>
           <a:ln>
             <a:noFill/>
@@ -3768,7 +3768,7 @@
           <a:lstStyle/>
           <a:p>
             <a:pPr algn="ctr">
-              <a:defRPr sz="1150" b="1">
+              <a:defRPr sz="1080" b="1">
                 <a:solidFill>
                   <a:srgbClr val="FFFFFF"/>
                 </a:solidFill>
@@ -3776,7 +3776,7 @@
               </a:defRPr>
             </a:pPr>
             <a:r>
-              <a:t>▲ THE PROBLEM (Current MoSPI Manual Survey)</a:t>
+              <a:t>CURRENT MoSPI FRAMEWORK: MANUAL FIELD SURVEY (THE PROBLEM)</a:t>
             </a:r>
           </a:p>
         </p:txBody>
@@ -3789,8 +3789,8 @@
         </p:nvSpPr>
         <p:spPr>
           <a:xfrm>
-            <a:off x="685800" y="1737360"/>
-            <a:ext cx="5074920" cy="2221992"/>
+            <a:off x="658368" y="1719072"/>
+            <a:ext cx="5148072" cy="2029968"/>
           </a:xfrm>
           <a:prstGeom prst="rect">
             <a:avLst/>
@@ -3808,7 +3808,7 @@
                 <a:spcPct val="115000"/>
               </a:lnSpc>
               <a:spcAft>
-                <a:spcPts val="500"/>
+                <a:spcPts val="400"/>
               </a:spcAft>
             </a:pPr>
             <a:r>
@@ -3823,11 +3823,11 @@
             <a:r>
               <a:rPr sz="980">
                 <a:solidFill>
-                  <a:srgbClr val="0F172A"/>
-                </a:solidFill>
-                <a:latin typeface="Arial"/>
-              </a:rPr>
-              <a:t>Manual surveyor visits delay CPI reporting by 2 weeks, missing high-frequency price volatility.</a:t>
+                  <a:srgbClr val="1E293B"/>
+                </a:solidFill>
+                <a:latin typeface="Arial"/>
+              </a:rPr>
+              <a:t>Manual surveyor visits delay CPI reporting by 2 weeks, missing rapid price volatility and holiday surges.</a:t>
             </a:r>
           </a:p>
           <a:p>
@@ -3836,7 +3836,7 @@
                 <a:spcPct val="115000"/>
               </a:lnSpc>
               <a:spcAft>
-                <a:spcPts val="500"/>
+                <a:spcPts val="400"/>
               </a:spcAft>
             </a:pPr>
             <a:r>
@@ -3851,11 +3851,11 @@
             <a:r>
               <a:rPr sz="980">
                 <a:solidFill>
-                  <a:srgbClr val="0F172A"/>
-                </a:solidFill>
-                <a:latin typeface="Arial"/>
-              </a:rPr>
-              <a:t>Only 1 quote collected per route/month, failing to capture 10,000+ daily dynamic algorithmic fares.</a:t>
+                  <a:srgbClr val="1E293B"/>
+                </a:solidFill>
+                <a:latin typeface="Arial"/>
+              </a:rPr>
+              <a:t>Only 1 physical quote collected per route/month, failing to capture 10,000+ daily dynamic pricing changes.</a:t>
             </a:r>
           </a:p>
           <a:p>
@@ -3864,7 +3864,7 @@
                 <a:spcPct val="115000"/>
               </a:lnSpc>
               <a:spcAft>
-                <a:spcPts val="500"/>
+                <a:spcPts val="400"/>
               </a:spcAft>
             </a:pPr>
             <a:r>
@@ -3879,11 +3879,11 @@
             <a:r>
               <a:rPr sz="980">
                 <a:solidFill>
-                  <a:srgbClr val="0F172A"/>
-                </a:solidFill>
-                <a:latin typeface="Arial"/>
-              </a:rPr>
-              <a:t>Arithmetic mean formula overstates airfare transport inflation by 20-30 bps.</a:t>
+                  <a:srgbClr val="1E293B"/>
+                </a:solidFill>
+                <a:latin typeface="Arial"/>
+              </a:rPr>
+              <a:t>Arithmetic mean price relatives structurally overstate airfare transport inflation by +20–30 bps (substitution bias).</a:t>
             </a:r>
           </a:p>
           <a:p>
@@ -3892,7 +3892,7 @@
                 <a:spcPct val="115000"/>
               </a:lnSpc>
               <a:spcAft>
-                <a:spcPts val="500"/>
+                <a:spcPts val="400"/>
               </a:spcAft>
             </a:pPr>
             <a:r>
@@ -3902,16 +3902,16 @@
                 </a:solidFill>
                 <a:latin typeface="Arial"/>
               </a:rPr>
-              <a:t>• High Operational Cost: </a:t>
+              <a:t>• High Operational Logistics: </a:t>
             </a:r>
             <a:r>
               <a:rPr sz="980">
                 <a:solidFill>
-                  <a:srgbClr val="0F172A"/>
-                </a:solidFill>
-                <a:latin typeface="Arial"/>
-              </a:rPr>
-              <a:t>Multi-crore physical surveyor logistics across airports with zero cryptographic audit trail.</a:t>
+                  <a:srgbClr val="1E293B"/>
+                </a:solidFill>
+                <a:latin typeface="Arial"/>
+              </a:rPr>
+              <a:t>Multi-crore physical airport field surveyor visits with zero cryptographic or verifiable audit trail.</a:t>
             </a:r>
           </a:p>
         </p:txBody>
@@ -3924,8 +3924,8 @@
         </p:nvSpPr>
         <p:spPr>
           <a:xfrm>
-            <a:off x="6245352" y="1298448"/>
-            <a:ext cx="5440680" cy="2697480"/>
+            <a:off x="6217920" y="1298448"/>
+            <a:ext cx="5468112" cy="2487168"/>
           </a:xfrm>
           <a:prstGeom prst="roundRect">
             <a:avLst>
@@ -3971,12 +3971,1059 @@
         </p:nvSpPr>
         <p:spPr>
           <a:xfrm>
-            <a:off x="6245352" y="1298448"/>
-            <a:ext cx="5440680" cy="384048"/>
+            <a:off x="6217920" y="1298448"/>
+            <a:ext cx="5468112" cy="384048"/>
+          </a:xfrm>
+          <a:prstGeom prst="roundRect">
+            <a:avLst>
+              <a:gd name="adj" fmla="val 18000"/>
+            </a:avLst>
+          </a:prstGeom>
+          <a:solidFill>
+            <a:srgbClr val="15803D"/>
+          </a:solidFill>
+          <a:ln>
+            <a:noFill/>
+          </a:ln>
+        </p:spPr>
+        <p:style>
+          <a:lnRef idx="1">
+            <a:schemeClr val="accent1"/>
+          </a:lnRef>
+          <a:fillRef idx="3">
+            <a:schemeClr val="accent1"/>
+          </a:fillRef>
+          <a:effectRef idx="2">
+            <a:schemeClr val="accent1"/>
+          </a:effectRef>
+          <a:fontRef idx="minor">
+            <a:schemeClr val="lt1"/>
+          </a:fontRef>
+        </p:style>
+        <p:txBody>
+          <a:bodyPr rtlCol="0" anchor="ctr"/>
+          <a:lstStyle/>
+          <a:p>
+            <a:pPr algn="ctr">
+              <a:defRPr sz="1080" b="1">
+                <a:solidFill>
+                  <a:srgbClr val="FFFFFF"/>
+                </a:solidFill>
+                <a:latin typeface="Arial"/>
+              </a:defRPr>
+            </a:pPr>
+            <a:r>
+              <a:t>VAYUSUCHAK AUTOMATED PIPELINE (HOW OUR SYSTEM SOLVES IT)</a:t>
+            </a:r>
+          </a:p>
+        </p:txBody>
+      </p:sp>
+      <p:sp>
+        <p:nvSpPr>
+          <p:cNvPr id="12" name="TextBox 11"/>
+          <p:cNvSpPr txBox="1"/>
+          <p:nvPr/>
+        </p:nvSpPr>
+        <p:spPr>
+          <a:xfrm>
+            <a:off x="6382512" y="1719072"/>
+            <a:ext cx="5148072" cy="2029968"/>
+          </a:xfrm>
+          <a:prstGeom prst="rect">
+            <a:avLst/>
+          </a:prstGeom>
+          <a:noFill/>
+        </p:spPr>
+        <p:txBody>
+          <a:bodyPr wrap="square">
+            <a:spAutoFit/>
+          </a:bodyPr>
+          <a:lstStyle/>
+          <a:p>
+            <a:pPr>
+              <a:lnSpc>
+                <a:spcPct val="115000"/>
+              </a:lnSpc>
+              <a:spcAft>
+                <a:spcPts val="400"/>
+              </a:spcAft>
+            </a:pPr>
+            <a:r>
+              <a:rPr sz="1019" b="1">
+                <a:solidFill>
+                  <a:srgbClr val="15803D"/>
+                </a:solidFill>
+                <a:latin typeface="Arial"/>
+              </a:rPr>
+              <a:t>• Automated Live Extraction: </a:t>
+            </a:r>
+            <a:r>
+              <a:rPr sz="980">
+                <a:solidFill>
+                  <a:srgbClr val="1E293B"/>
+                </a:solidFill>
+                <a:latin typeface="Arial"/>
+              </a:rPr>
+              <a:t>Distributed Playwright bots harvest 10,000+ live fares daily with sub-24h latency at 02:00 AM IST.</a:t>
+            </a:r>
+          </a:p>
+          <a:p>
+            <a:pPr>
+              <a:lnSpc>
+                <a:spcPct val="115000"/>
+              </a:lnSpc>
+              <a:spcAft>
+                <a:spcPts val="400"/>
+              </a:spcAft>
+            </a:pPr>
+            <a:r>
+              <a:rPr sz="1019" b="1">
+                <a:solidFill>
+                  <a:srgbClr val="15803D"/>
+                </a:solidFill>
+                <a:latin typeface="Arial"/>
+              </a:rPr>
+              <a:t>• T+1..T+45 Advance Horizons: </a:t>
+            </a:r>
+            <a:r>
+              <a:rPr sz="980">
+                <a:solidFill>
+                  <a:srgbClr val="1E293B"/>
+                </a:solidFill>
+                <a:latin typeface="Arial"/>
+              </a:rPr>
+              <a:t>Captures urgent vs saver booking curves weighted dynamically by official DGCA passenger volume shares.</a:t>
+            </a:r>
+          </a:p>
+          <a:p>
+            <a:pPr>
+              <a:lnSpc>
+                <a:spcPct val="115000"/>
+              </a:lnSpc>
+              <a:spcAft>
+                <a:spcPts val="400"/>
+              </a:spcAft>
+            </a:pPr>
+            <a:r>
+              <a:rPr sz="1019" b="1">
+                <a:solidFill>
+                  <a:srgbClr val="15803D"/>
+                </a:solidFill>
+                <a:latin typeface="Arial"/>
+              </a:rPr>
+              <a:t>• UN/ILO Jevons Index: </a:t>
+            </a:r>
+            <a:r>
+              <a:rPr sz="980">
+                <a:solidFill>
+                  <a:srgbClr val="1E293B"/>
+                </a:solidFill>
+                <a:latin typeface="Arial"/>
+              </a:rPr>
+              <a:t>Geometric mean formula eliminates Dutot substitution bias, delivering an axiomatic 0.0% distortion index.</a:t>
+            </a:r>
+          </a:p>
+          <a:p>
+            <a:pPr>
+              <a:lnSpc>
+                <a:spcPct val="115000"/>
+              </a:lnSpc>
+              <a:spcAft>
+                <a:spcPts val="400"/>
+              </a:spcAft>
+            </a:pPr>
+            <a:r>
+              <a:rPr sz="1019" b="1">
+                <a:solidFill>
+                  <a:srgbClr val="15803D"/>
+                </a:solidFill>
+                <a:latin typeface="Arial"/>
+              </a:rPr>
+              <a:t>• Sovereign Audit Ledger: </a:t>
+            </a:r>
+            <a:r>
+              <a:rPr sz="980">
+                <a:solidFill>
+                  <a:srgbClr val="1E293B"/>
+                </a:solidFill>
+                <a:latin typeface="Arial"/>
+              </a:rPr>
+              <a:t>SHA-256 Merkle tree fingerprints guarantee tamper-proof legal evidentiary auditability for MoSPI &amp; RBI.</a:t>
+            </a:r>
+          </a:p>
+        </p:txBody>
+      </p:sp>
+      <p:sp>
+        <p:nvSpPr>
+          <p:cNvPr id="13" name="Rounded Rectangle 12"/>
+          <p:cNvSpPr/>
+          <p:nvPr/>
+        </p:nvSpPr>
+        <p:spPr>
+          <a:xfrm>
+            <a:off x="502920" y="3950208"/>
+            <a:ext cx="2103120" cy="2697480"/>
+          </a:xfrm>
+          <a:prstGeom prst="roundRect">
+            <a:avLst>
+              <a:gd name="adj" fmla="val 5000"/>
+            </a:avLst>
+          </a:prstGeom>
+          <a:solidFill>
+            <a:srgbClr val="FFFFFF"/>
+          </a:solidFill>
+          <a:ln w="19050">
+            <a:solidFill>
+              <a:srgbClr val="3B82F6"/>
+            </a:solidFill>
+          </a:ln>
+        </p:spPr>
+        <p:style>
+          <a:lnRef idx="1">
+            <a:schemeClr val="accent1"/>
+          </a:lnRef>
+          <a:fillRef idx="3">
+            <a:schemeClr val="accent1"/>
+          </a:fillRef>
+          <a:effectRef idx="2">
+            <a:schemeClr val="accent1"/>
+          </a:effectRef>
+          <a:fontRef idx="minor">
+            <a:schemeClr val="lt1"/>
+          </a:fontRef>
+        </p:style>
+        <p:txBody>
+          <a:bodyPr rtlCol="0" anchor="ctr"/>
+          <a:lstStyle/>
+          <a:p>
+            <a:pPr algn="ctr"/>
+          </a:p>
+        </p:txBody>
+      </p:sp>
+      <p:sp>
+        <p:nvSpPr>
+          <p:cNvPr id="14" name="Rounded Rectangle 13"/>
+          <p:cNvSpPr/>
+          <p:nvPr/>
+        </p:nvSpPr>
+        <p:spPr>
+          <a:xfrm>
+            <a:off x="502920" y="3950208"/>
+            <a:ext cx="2103120" cy="365760"/>
+          </a:xfrm>
+          <a:prstGeom prst="roundRect">
+            <a:avLst>
+              <a:gd name="adj" fmla="val 18000"/>
+            </a:avLst>
+          </a:prstGeom>
+          <a:solidFill>
+            <a:srgbClr val="1E40AF"/>
+          </a:solidFill>
+          <a:ln>
+            <a:noFill/>
+          </a:ln>
+        </p:spPr>
+        <p:style>
+          <a:lnRef idx="1">
+            <a:schemeClr val="accent1"/>
+          </a:lnRef>
+          <a:fillRef idx="3">
+            <a:schemeClr val="accent1"/>
+          </a:fillRef>
+          <a:effectRef idx="2">
+            <a:schemeClr val="accent1"/>
+          </a:effectRef>
+          <a:fontRef idx="minor">
+            <a:schemeClr val="lt1"/>
+          </a:fontRef>
+        </p:style>
+        <p:txBody>
+          <a:bodyPr rtlCol="0" anchor="ctr"/>
+          <a:lstStyle/>
+          <a:p>
+            <a:pPr algn="ctr">
+              <a:defRPr sz="1100" b="1">
+                <a:solidFill>
+                  <a:srgbClr val="FFFFFF"/>
+                </a:solidFill>
+                <a:latin typeface="Arial"/>
+              </a:defRPr>
+            </a:pPr>
+            <a:r>
+              <a:t>STEP 01</a:t>
+            </a:r>
+          </a:p>
+        </p:txBody>
+      </p:sp>
+      <p:sp>
+        <p:nvSpPr>
+          <p:cNvPr id="15" name="TextBox 14"/>
+          <p:cNvSpPr txBox="1"/>
+          <p:nvPr/>
+        </p:nvSpPr>
+        <p:spPr>
+          <a:xfrm>
+            <a:off x="594360" y="4361688"/>
+            <a:ext cx="1920240" cy="1828800"/>
+          </a:xfrm>
+          <a:prstGeom prst="rect">
+            <a:avLst/>
+          </a:prstGeom>
+          <a:noFill/>
+        </p:spPr>
+        <p:txBody>
+          <a:bodyPr wrap="square" tIns="0" bIns="0" lIns="0" rIns="0">
+            <a:spAutoFit/>
+          </a:bodyPr>
+          <a:lstStyle/>
+          <a:p>
+            <a:pPr algn="ctr">
+              <a:spcAft>
+                <a:spcPts val="200"/>
+              </a:spcAft>
+              <a:defRPr sz="1150" b="1">
+                <a:solidFill>
+                  <a:srgbClr val="1E40AF"/>
+                </a:solidFill>
+                <a:latin typeface="Arial"/>
+              </a:defRPr>
+            </a:pPr>
+            <a:r>
+              <a:t>Dynamic Yield</a:t>
+            </a:r>
+            <a:br/>
+            <a:r>
+              <a:t>Tracking</a:t>
+            </a:r>
+          </a:p>
+          <a:p>
+            <a:pPr algn="ctr">
+              <a:spcAft>
+                <a:spcPts val="600"/>
+              </a:spcAft>
+              <a:defRPr sz="900" b="1">
+                <a:solidFill>
+                  <a:srgbClr val="64748B"/>
+                </a:solidFill>
+                <a:latin typeface="Arial"/>
+              </a:defRPr>
+            </a:pPr>
+            <a:r>
+              <a:t>• T+1..T+45 Windows •</a:t>
+            </a:r>
+          </a:p>
+          <a:p>
+            <a:pPr algn="l">
+              <a:lnSpc>
+                <a:spcPct val="118000"/>
+              </a:lnSpc>
+              <a:defRPr sz="960">
+                <a:solidFill>
+                  <a:srgbClr val="1E293B"/>
+                </a:solidFill>
+                <a:latin typeface="Arial"/>
+              </a:defRPr>
+            </a:pPr>
+            <a:r>
+              <a:t>Captures intraday surges across T+1..T+45 advance booking windows.</a:t>
+            </a:r>
+          </a:p>
+        </p:txBody>
+      </p:sp>
+      <p:sp>
+        <p:nvSpPr>
+          <p:cNvPr id="16" name="Rounded Rectangle 15"/>
+          <p:cNvSpPr/>
+          <p:nvPr/>
+        </p:nvSpPr>
+        <p:spPr>
+          <a:xfrm>
+            <a:off x="576072" y="6263640"/>
+            <a:ext cx="1956816" cy="310896"/>
           </a:xfrm>
           <a:prstGeom prst="roundRect">
             <a:avLst>
               <a:gd name="adj" fmla="val 20000"/>
+            </a:avLst>
+          </a:prstGeom>
+          <a:solidFill>
+            <a:srgbClr val="EFF6FF"/>
+          </a:solidFill>
+          <a:ln w="12700">
+            <a:solidFill>
+              <a:srgbClr val="3B82F6"/>
+            </a:solidFill>
+          </a:ln>
+        </p:spPr>
+        <p:style>
+          <a:lnRef idx="1">
+            <a:schemeClr val="accent1"/>
+          </a:lnRef>
+          <a:fillRef idx="3">
+            <a:schemeClr val="accent1"/>
+          </a:fillRef>
+          <a:effectRef idx="2">
+            <a:schemeClr val="accent1"/>
+          </a:effectRef>
+          <a:fontRef idx="minor">
+            <a:schemeClr val="lt1"/>
+          </a:fontRef>
+        </p:style>
+        <p:txBody>
+          <a:bodyPr rtlCol="0" anchor="ctr"/>
+          <a:lstStyle/>
+          <a:p>
+            <a:pPr algn="ctr">
+              <a:defRPr sz="850" b="1">
+                <a:solidFill>
+                  <a:srgbClr val="1E40AF"/>
+                </a:solidFill>
+                <a:latin typeface="Arial"/>
+              </a:defRPr>
+            </a:pPr>
+            <a:r>
+              <a:t>Playwright Scraper | 10,000+ Fares/Day</a:t>
+            </a:r>
+          </a:p>
+        </p:txBody>
+      </p:sp>
+      <p:sp>
+        <p:nvSpPr>
+          <p:cNvPr id="17" name="TextBox 16"/>
+          <p:cNvSpPr txBox="1"/>
+          <p:nvPr/>
+        </p:nvSpPr>
+        <p:spPr>
+          <a:xfrm>
+            <a:off x="2615184" y="5001768"/>
+            <a:ext cx="146304" cy="365760"/>
+          </a:xfrm>
+          <a:prstGeom prst="rect">
+            <a:avLst/>
+          </a:prstGeom>
+          <a:noFill/>
+        </p:spPr>
+        <p:txBody>
+          <a:bodyPr wrap="none" lIns="0" tIns="0" rIns="0" bIns="0">
+            <a:spAutoFit/>
+          </a:bodyPr>
+          <a:lstStyle/>
+          <a:p>
+            <a:pPr algn="ctr">
+              <a:defRPr sz="1500" b="1">
+                <a:solidFill>
+                  <a:srgbClr val="94A3B8"/>
+                </a:solidFill>
+                <a:latin typeface="Arial"/>
+              </a:defRPr>
+            </a:pPr>
+            <a:r>
+              <a:t>➔</a:t>
+            </a:r>
+          </a:p>
+        </p:txBody>
+      </p:sp>
+      <p:sp>
+        <p:nvSpPr>
+          <p:cNvPr id="18" name="Rounded Rectangle 17"/>
+          <p:cNvSpPr/>
+          <p:nvPr/>
+        </p:nvSpPr>
+        <p:spPr>
+          <a:xfrm>
+            <a:off x="2770632" y="3950208"/>
+            <a:ext cx="2103120" cy="2697480"/>
+          </a:xfrm>
+          <a:prstGeom prst="roundRect">
+            <a:avLst>
+              <a:gd name="adj" fmla="val 5000"/>
+            </a:avLst>
+          </a:prstGeom>
+          <a:solidFill>
+            <a:srgbClr val="FFFFFF"/>
+          </a:solidFill>
+          <a:ln w="19050">
+            <a:solidFill>
+              <a:srgbClr val="0EA5E9"/>
+            </a:solidFill>
+          </a:ln>
+        </p:spPr>
+        <p:style>
+          <a:lnRef idx="1">
+            <a:schemeClr val="accent1"/>
+          </a:lnRef>
+          <a:fillRef idx="3">
+            <a:schemeClr val="accent1"/>
+          </a:fillRef>
+          <a:effectRef idx="2">
+            <a:schemeClr val="accent1"/>
+          </a:effectRef>
+          <a:fontRef idx="minor">
+            <a:schemeClr val="lt1"/>
+          </a:fontRef>
+        </p:style>
+        <p:txBody>
+          <a:bodyPr rtlCol="0" anchor="ctr"/>
+          <a:lstStyle/>
+          <a:p>
+            <a:pPr algn="ctr"/>
+          </a:p>
+        </p:txBody>
+      </p:sp>
+      <p:sp>
+        <p:nvSpPr>
+          <p:cNvPr id="19" name="Rounded Rectangle 18"/>
+          <p:cNvSpPr/>
+          <p:nvPr/>
+        </p:nvSpPr>
+        <p:spPr>
+          <a:xfrm>
+            <a:off x="2770632" y="3950208"/>
+            <a:ext cx="2103120" cy="365760"/>
+          </a:xfrm>
+          <a:prstGeom prst="roundRect">
+            <a:avLst>
+              <a:gd name="adj" fmla="val 18000"/>
+            </a:avLst>
+          </a:prstGeom>
+          <a:solidFill>
+            <a:srgbClr val="0284C7"/>
+          </a:solidFill>
+          <a:ln>
+            <a:noFill/>
+          </a:ln>
+        </p:spPr>
+        <p:style>
+          <a:lnRef idx="1">
+            <a:schemeClr val="accent1"/>
+          </a:lnRef>
+          <a:fillRef idx="3">
+            <a:schemeClr val="accent1"/>
+          </a:fillRef>
+          <a:effectRef idx="2">
+            <a:schemeClr val="accent1"/>
+          </a:effectRef>
+          <a:fontRef idx="minor">
+            <a:schemeClr val="lt1"/>
+          </a:fontRef>
+        </p:style>
+        <p:txBody>
+          <a:bodyPr rtlCol="0" anchor="ctr"/>
+          <a:lstStyle/>
+          <a:p>
+            <a:pPr algn="ctr">
+              <a:defRPr sz="1100" b="1">
+                <a:solidFill>
+                  <a:srgbClr val="FFFFFF"/>
+                </a:solidFill>
+                <a:latin typeface="Arial"/>
+              </a:defRPr>
+            </a:pPr>
+            <a:r>
+              <a:t>STEP 02</a:t>
+            </a:r>
+          </a:p>
+        </p:txBody>
+      </p:sp>
+      <p:sp>
+        <p:nvSpPr>
+          <p:cNvPr id="20" name="TextBox 19"/>
+          <p:cNvSpPr txBox="1"/>
+          <p:nvPr/>
+        </p:nvSpPr>
+        <p:spPr>
+          <a:xfrm>
+            <a:off x="2862072" y="4361688"/>
+            <a:ext cx="1920240" cy="1828800"/>
+          </a:xfrm>
+          <a:prstGeom prst="rect">
+            <a:avLst/>
+          </a:prstGeom>
+          <a:noFill/>
+        </p:spPr>
+        <p:txBody>
+          <a:bodyPr wrap="square" tIns="0" bIns="0" lIns="0" rIns="0">
+            <a:spAutoFit/>
+          </a:bodyPr>
+          <a:lstStyle/>
+          <a:p>
+            <a:pPr algn="ctr">
+              <a:spcAft>
+                <a:spcPts val="200"/>
+              </a:spcAft>
+              <a:defRPr sz="1150" b="1">
+                <a:solidFill>
+                  <a:srgbClr val="0284C7"/>
+                </a:solidFill>
+                <a:latin typeface="Arial"/>
+              </a:defRPr>
+            </a:pPr>
+            <a:r>
+              <a:t>Dynamic IQR</a:t>
+            </a:r>
+            <a:br/>
+            <a:r>
+              <a:t>Scrubber</a:t>
+            </a:r>
+          </a:p>
+          <a:p>
+            <a:pPr algn="ctr">
+              <a:spcAft>
+                <a:spcPts val="600"/>
+              </a:spcAft>
+              <a:defRPr sz="900" b="1">
+                <a:solidFill>
+                  <a:srgbClr val="64748B"/>
+                </a:solidFill>
+                <a:latin typeface="Arial"/>
+              </a:defRPr>
+            </a:pPr>
+            <a:r>
+              <a:t>• Base Fare Isolation •</a:t>
+            </a:r>
+          </a:p>
+          <a:p>
+            <a:pPr algn="l">
+              <a:lnSpc>
+                <a:spcPct val="118000"/>
+              </a:lnSpc>
+              <a:defRPr sz="960">
+                <a:solidFill>
+                  <a:srgbClr val="1E293B"/>
+                </a:solidFill>
+                <a:latin typeface="Arial"/>
+              </a:defRPr>
+            </a:pPr>
+            <a:r>
+              <a:t>Isolates base fares and purges phantom prices and cache glitches.</a:t>
+            </a:r>
+          </a:p>
+        </p:txBody>
+      </p:sp>
+      <p:sp>
+        <p:nvSpPr>
+          <p:cNvPr id="21" name="Rounded Rectangle 20"/>
+          <p:cNvSpPr/>
+          <p:nvPr/>
+        </p:nvSpPr>
+        <p:spPr>
+          <a:xfrm>
+            <a:off x="2843784" y="6263640"/>
+            <a:ext cx="1956816" cy="310896"/>
+          </a:xfrm>
+          <a:prstGeom prst="roundRect">
+            <a:avLst>
+              <a:gd name="adj" fmla="val 20000"/>
+            </a:avLst>
+          </a:prstGeom>
+          <a:solidFill>
+            <a:srgbClr val="F0F9FF"/>
+          </a:solidFill>
+          <a:ln w="12700">
+            <a:solidFill>
+              <a:srgbClr val="0EA5E9"/>
+            </a:solidFill>
+          </a:ln>
+        </p:spPr>
+        <p:style>
+          <a:lnRef idx="1">
+            <a:schemeClr val="accent1"/>
+          </a:lnRef>
+          <a:fillRef idx="3">
+            <a:schemeClr val="accent1"/>
+          </a:fillRef>
+          <a:effectRef idx="2">
+            <a:schemeClr val="accent1"/>
+          </a:effectRef>
+          <a:fontRef idx="minor">
+            <a:schemeClr val="lt1"/>
+          </a:fontRef>
+        </p:style>
+        <p:txBody>
+          <a:bodyPr rtlCol="0" anchor="ctr"/>
+          <a:lstStyle/>
+          <a:p>
+            <a:pPr algn="ctr">
+              <a:defRPr sz="850" b="1">
+                <a:solidFill>
+                  <a:srgbClr val="0284C7"/>
+                </a:solidFill>
+                <a:latin typeface="Arial"/>
+              </a:defRPr>
+            </a:pPr>
+            <a:r>
+              <a:t>SciPy Truncation | Outlier Purged</a:t>
+            </a:r>
+          </a:p>
+        </p:txBody>
+      </p:sp>
+      <p:sp>
+        <p:nvSpPr>
+          <p:cNvPr id="22" name="TextBox 21"/>
+          <p:cNvSpPr txBox="1"/>
+          <p:nvPr/>
+        </p:nvSpPr>
+        <p:spPr>
+          <a:xfrm>
+            <a:off x="4882896" y="5001768"/>
+            <a:ext cx="146304" cy="365760"/>
+          </a:xfrm>
+          <a:prstGeom prst="rect">
+            <a:avLst/>
+          </a:prstGeom>
+          <a:noFill/>
+        </p:spPr>
+        <p:txBody>
+          <a:bodyPr wrap="none" lIns="0" tIns="0" rIns="0" bIns="0">
+            <a:spAutoFit/>
+          </a:bodyPr>
+          <a:lstStyle/>
+          <a:p>
+            <a:pPr algn="ctr">
+              <a:defRPr sz="1500" b="1">
+                <a:solidFill>
+                  <a:srgbClr val="94A3B8"/>
+                </a:solidFill>
+                <a:latin typeface="Arial"/>
+              </a:defRPr>
+            </a:pPr>
+            <a:r>
+              <a:t>➔</a:t>
+            </a:r>
+          </a:p>
+        </p:txBody>
+      </p:sp>
+      <p:sp>
+        <p:nvSpPr>
+          <p:cNvPr id="23" name="Rounded Rectangle 22"/>
+          <p:cNvSpPr/>
+          <p:nvPr/>
+        </p:nvSpPr>
+        <p:spPr>
+          <a:xfrm>
+            <a:off x="5038344" y="3950208"/>
+            <a:ext cx="2103120" cy="2697480"/>
+          </a:xfrm>
+          <a:prstGeom prst="roundRect">
+            <a:avLst>
+              <a:gd name="adj" fmla="val 5000"/>
+            </a:avLst>
+          </a:prstGeom>
+          <a:solidFill>
+            <a:srgbClr val="FFFFFF"/>
+          </a:solidFill>
+          <a:ln w="19050">
+            <a:solidFill>
+              <a:srgbClr val="14B8A6"/>
+            </a:solidFill>
+          </a:ln>
+        </p:spPr>
+        <p:style>
+          <a:lnRef idx="1">
+            <a:schemeClr val="accent1"/>
+          </a:lnRef>
+          <a:fillRef idx="3">
+            <a:schemeClr val="accent1"/>
+          </a:fillRef>
+          <a:effectRef idx="2">
+            <a:schemeClr val="accent1"/>
+          </a:effectRef>
+          <a:fontRef idx="minor">
+            <a:schemeClr val="lt1"/>
+          </a:fontRef>
+        </p:style>
+        <p:txBody>
+          <a:bodyPr rtlCol="0" anchor="ctr"/>
+          <a:lstStyle/>
+          <a:p>
+            <a:pPr algn="ctr"/>
+          </a:p>
+        </p:txBody>
+      </p:sp>
+      <p:sp>
+        <p:nvSpPr>
+          <p:cNvPr id="24" name="Rounded Rectangle 23"/>
+          <p:cNvSpPr/>
+          <p:nvPr/>
+        </p:nvSpPr>
+        <p:spPr>
+          <a:xfrm>
+            <a:off x="5038344" y="3950208"/>
+            <a:ext cx="2103120" cy="365760"/>
+          </a:xfrm>
+          <a:prstGeom prst="roundRect">
+            <a:avLst>
+              <a:gd name="adj" fmla="val 18000"/>
+            </a:avLst>
+          </a:prstGeom>
+          <a:solidFill>
+            <a:srgbClr val="0D9488"/>
+          </a:solidFill>
+          <a:ln>
+            <a:noFill/>
+          </a:ln>
+        </p:spPr>
+        <p:style>
+          <a:lnRef idx="1">
+            <a:schemeClr val="accent1"/>
+          </a:lnRef>
+          <a:fillRef idx="3">
+            <a:schemeClr val="accent1"/>
+          </a:fillRef>
+          <a:effectRef idx="2">
+            <a:schemeClr val="accent1"/>
+          </a:effectRef>
+          <a:fontRef idx="minor">
+            <a:schemeClr val="lt1"/>
+          </a:fontRef>
+        </p:style>
+        <p:txBody>
+          <a:bodyPr rtlCol="0" anchor="ctr"/>
+          <a:lstStyle/>
+          <a:p>
+            <a:pPr algn="ctr">
+              <a:defRPr sz="1100" b="1">
+                <a:solidFill>
+                  <a:srgbClr val="FFFFFF"/>
+                </a:solidFill>
+                <a:latin typeface="Arial"/>
+              </a:defRPr>
+            </a:pPr>
+            <a:r>
+              <a:t>STEP 03</a:t>
+            </a:r>
+          </a:p>
+        </p:txBody>
+      </p:sp>
+      <p:sp>
+        <p:nvSpPr>
+          <p:cNvPr id="25" name="TextBox 24"/>
+          <p:cNvSpPr txBox="1"/>
+          <p:nvPr/>
+        </p:nvSpPr>
+        <p:spPr>
+          <a:xfrm>
+            <a:off x="5129784" y="4361688"/>
+            <a:ext cx="1920240" cy="1828800"/>
+          </a:xfrm>
+          <a:prstGeom prst="rect">
+            <a:avLst/>
+          </a:prstGeom>
+          <a:noFill/>
+        </p:spPr>
+        <p:txBody>
+          <a:bodyPr wrap="square" tIns="0" bIns="0" lIns="0" rIns="0">
+            <a:spAutoFit/>
+          </a:bodyPr>
+          <a:lstStyle/>
+          <a:p>
+            <a:pPr algn="ctr">
+              <a:spcAft>
+                <a:spcPts val="200"/>
+              </a:spcAft>
+              <a:defRPr sz="1150" b="1">
+                <a:solidFill>
+                  <a:srgbClr val="0D9488"/>
+                </a:solidFill>
+                <a:latin typeface="Arial"/>
+              </a:defRPr>
+            </a:pPr>
+            <a:r>
+              <a:t>UN/ILO Jevons</a:t>
+            </a:r>
+            <a:br/>
+            <a:r>
+              <a:t>Index Engine</a:t>
+            </a:r>
+          </a:p>
+          <a:p>
+            <a:pPr algn="ctr">
+              <a:spcAft>
+                <a:spcPts val="600"/>
+              </a:spcAft>
+              <a:defRPr sz="900" b="1">
+                <a:solidFill>
+                  <a:srgbClr val="64748B"/>
+                </a:solidFill>
+                <a:latin typeface="Arial"/>
+              </a:defRPr>
+            </a:pPr>
+            <a:r>
+              <a:t>• Geometric Mean •</a:t>
+            </a:r>
+          </a:p>
+          <a:p>
+            <a:pPr algn="l">
+              <a:lnSpc>
+                <a:spcPct val="118000"/>
+              </a:lnSpc>
+              <a:defRPr sz="960">
+                <a:solidFill>
+                  <a:srgbClr val="1E293B"/>
+                </a:solidFill>
+                <a:latin typeface="Arial"/>
+              </a:defRPr>
+            </a:pPr>
+            <a:r>
+              <a:t>Geometric mean calculation that eliminates upward substitution bias.</a:t>
+            </a:r>
+          </a:p>
+        </p:txBody>
+      </p:sp>
+      <p:sp>
+        <p:nvSpPr>
+          <p:cNvPr id="26" name="Rounded Rectangle 25"/>
+          <p:cNvSpPr/>
+          <p:nvPr/>
+        </p:nvSpPr>
+        <p:spPr>
+          <a:xfrm>
+            <a:off x="5111496" y="6263640"/>
+            <a:ext cx="1956816" cy="310896"/>
+          </a:xfrm>
+          <a:prstGeom prst="roundRect">
+            <a:avLst>
+              <a:gd name="adj" fmla="val 20000"/>
+            </a:avLst>
+          </a:prstGeom>
+          <a:solidFill>
+            <a:srgbClr val="F0FDFA"/>
+          </a:solidFill>
+          <a:ln w="12700">
+            <a:solidFill>
+              <a:srgbClr val="14B8A6"/>
+            </a:solidFill>
+          </a:ln>
+        </p:spPr>
+        <p:style>
+          <a:lnRef idx="1">
+            <a:schemeClr val="accent1"/>
+          </a:lnRef>
+          <a:fillRef idx="3">
+            <a:schemeClr val="accent1"/>
+          </a:fillRef>
+          <a:effectRef idx="2">
+            <a:schemeClr val="accent1"/>
+          </a:effectRef>
+          <a:fontRef idx="minor">
+            <a:schemeClr val="lt1"/>
+          </a:fontRef>
+        </p:style>
+        <p:txBody>
+          <a:bodyPr rtlCol="0" anchor="ctr"/>
+          <a:lstStyle/>
+          <a:p>
+            <a:pPr algn="ctr">
+              <a:defRPr sz="850" b="1">
+                <a:solidFill>
+                  <a:srgbClr val="0D9488"/>
+                </a:solidFill>
+                <a:latin typeface="Arial"/>
+              </a:defRPr>
+            </a:pPr>
+            <a:r>
+              <a:t>UN/ILO Ch. 10 Math | 0.0% Upward Bias</a:t>
+            </a:r>
+          </a:p>
+        </p:txBody>
+      </p:sp>
+      <p:sp>
+        <p:nvSpPr>
+          <p:cNvPr id="27" name="TextBox 26"/>
+          <p:cNvSpPr txBox="1"/>
+          <p:nvPr/>
+        </p:nvSpPr>
+        <p:spPr>
+          <a:xfrm>
+            <a:off x="7150608" y="5001768"/>
+            <a:ext cx="146304" cy="365760"/>
+          </a:xfrm>
+          <a:prstGeom prst="rect">
+            <a:avLst/>
+          </a:prstGeom>
+          <a:noFill/>
+        </p:spPr>
+        <p:txBody>
+          <a:bodyPr wrap="none" lIns="0" tIns="0" rIns="0" bIns="0">
+            <a:spAutoFit/>
+          </a:bodyPr>
+          <a:lstStyle/>
+          <a:p>
+            <a:pPr algn="ctr">
+              <a:defRPr sz="1500" b="1">
+                <a:solidFill>
+                  <a:srgbClr val="94A3B8"/>
+                </a:solidFill>
+                <a:latin typeface="Arial"/>
+              </a:defRPr>
+            </a:pPr>
+            <a:r>
+              <a:t>➔</a:t>
+            </a:r>
+          </a:p>
+        </p:txBody>
+      </p:sp>
+      <p:sp>
+        <p:nvSpPr>
+          <p:cNvPr id="28" name="Rounded Rectangle 27"/>
+          <p:cNvSpPr/>
+          <p:nvPr/>
+        </p:nvSpPr>
+        <p:spPr>
+          <a:xfrm>
+            <a:off x="7306056" y="3950208"/>
+            <a:ext cx="2103120" cy="2697480"/>
+          </a:xfrm>
+          <a:prstGeom prst="roundRect">
+            <a:avLst>
+              <a:gd name="adj" fmla="val 5000"/>
+            </a:avLst>
+          </a:prstGeom>
+          <a:solidFill>
+            <a:srgbClr val="FFFFFF"/>
+          </a:solidFill>
+          <a:ln w="19050">
+            <a:solidFill>
+              <a:srgbClr val="22C55E"/>
+            </a:solidFill>
+          </a:ln>
+        </p:spPr>
+        <p:style>
+          <a:lnRef idx="1">
+            <a:schemeClr val="accent1"/>
+          </a:lnRef>
+          <a:fillRef idx="3">
+            <a:schemeClr val="accent1"/>
+          </a:fillRef>
+          <a:effectRef idx="2">
+            <a:schemeClr val="accent1"/>
+          </a:effectRef>
+          <a:fontRef idx="minor">
+            <a:schemeClr val="lt1"/>
+          </a:fontRef>
+        </p:style>
+        <p:txBody>
+          <a:bodyPr rtlCol="0" anchor="ctr"/>
+          <a:lstStyle/>
+          <a:p>
+            <a:pPr algn="ctr"/>
+          </a:p>
+        </p:txBody>
+      </p:sp>
+      <p:sp>
+        <p:nvSpPr>
+          <p:cNvPr id="29" name="Rounded Rectangle 28"/>
+          <p:cNvSpPr/>
+          <p:nvPr/>
+        </p:nvSpPr>
+        <p:spPr>
+          <a:xfrm>
+            <a:off x="7306056" y="3950208"/>
+            <a:ext cx="2103120" cy="365760"/>
+          </a:xfrm>
+          <a:prstGeom prst="roundRect">
+            <a:avLst>
+              <a:gd name="adj" fmla="val 18000"/>
             </a:avLst>
           </a:prstGeom>
           <a:solidFill>
@@ -4005,7 +5052,7 @@
           <a:lstStyle/>
           <a:p>
             <a:pPr algn="ctr">
-              <a:defRPr sz="1150" b="1">
+              <a:defRPr sz="1100" b="1">
                 <a:solidFill>
                   <a:srgbClr val="FFFFFF"/>
                 </a:solidFill>
@@ -4013,21 +5060,21 @@
               </a:defRPr>
             </a:pPr>
             <a:r>
-              <a:t>▶ HOW OUR APP SOLVES IT (VayuSuchak Engine)</a:t>
-            </a:r>
-          </a:p>
-        </p:txBody>
-      </p:sp>
-      <p:sp>
-        <p:nvSpPr>
-          <p:cNvPr id="12" name="TextBox 11"/>
+              <a:t>STEP 04</a:t>
+            </a:r>
+          </a:p>
+        </p:txBody>
+      </p:sp>
+      <p:sp>
+        <p:nvSpPr>
+          <p:cNvPr id="30" name="TextBox 29"/>
           <p:cNvSpPr txBox="1"/>
           <p:nvPr/>
         </p:nvSpPr>
         <p:spPr>
           <a:xfrm>
-            <a:off x="6428232" y="1737360"/>
-            <a:ext cx="5074920" cy="2221992"/>
+            <a:off x="7397496" y="4361688"/>
+            <a:ext cx="1920240" cy="1828800"/>
           </a:xfrm>
           <a:prstGeom prst="rect">
             <a:avLst/>
@@ -4035,158 +5082,74 @@
           <a:noFill/>
         </p:spPr>
         <p:txBody>
-          <a:bodyPr wrap="square">
+          <a:bodyPr wrap="square" tIns="0" bIns="0" lIns="0" rIns="0">
             <a:spAutoFit/>
           </a:bodyPr>
           <a:lstStyle/>
           <a:p>
-            <a:pPr>
+            <a:pPr algn="ctr">
+              <a:spcAft>
+                <a:spcPts val="200"/>
+              </a:spcAft>
+              <a:defRPr sz="1150" b="1">
+                <a:solidFill>
+                  <a:srgbClr val="16A34A"/>
+                </a:solidFill>
+                <a:latin typeface="Arial"/>
+              </a:defRPr>
+            </a:pPr>
+            <a:r>
+              <a:t>Sovereign Audit</a:t>
+            </a:r>
+            <a:br/>
+            <a:r>
+              <a:t>Vault</a:t>
+            </a:r>
+          </a:p>
+          <a:p>
+            <a:pPr algn="ctr">
+              <a:spcAft>
+                <a:spcPts val="600"/>
+              </a:spcAft>
+              <a:defRPr sz="900" b="1">
+                <a:solidFill>
+                  <a:srgbClr val="64748B"/>
+                </a:solidFill>
+                <a:latin typeface="Arial"/>
+              </a:defRPr>
+            </a:pPr>
+            <a:r>
+              <a:t>• Cryptographic Proofs •</a:t>
+            </a:r>
+          </a:p>
+          <a:p>
+            <a:pPr algn="l">
               <a:lnSpc>
-                <a:spcPct val="115000"/>
+                <a:spcPct val="118000"/>
               </a:lnSpc>
-              <a:spcAft>
-                <a:spcPts val="500"/>
-              </a:spcAft>
-            </a:pPr>
-            <a:r>
-              <a:rPr sz="1019" b="1">
-                <a:solidFill>
-                  <a:srgbClr val="15803D"/>
-                </a:solidFill>
-                <a:latin typeface="Arial"/>
-              </a:rPr>
-              <a:t>• Real-Time Extraction: </a:t>
-            </a:r>
-            <a:r>
-              <a:rPr sz="980">
-                <a:solidFill>
-                  <a:srgbClr val="0F172A"/>
-                </a:solidFill>
-                <a:latin typeface="Arial"/>
-              </a:rPr>
-              <a:t>Playwright headless bots harvest 10,000+ live fares daily with sub-24h latency at 02:00 AM IST.</a:t>
-            </a:r>
-          </a:p>
-          <a:p>
-            <a:pPr>
-              <a:lnSpc>
-                <a:spcPct val="115000"/>
-              </a:lnSpc>
-              <a:spcAft>
-                <a:spcPts val="500"/>
-              </a:spcAft>
-            </a:pPr>
-            <a:r>
-              <a:rPr sz="1019" b="1">
-                <a:solidFill>
-                  <a:srgbClr val="15803D"/>
-                </a:solidFill>
-                <a:latin typeface="Arial"/>
-              </a:rPr>
-              <a:t>• T+1..T+45 Advance Horizons: </a:t>
-            </a:r>
-            <a:r>
-              <a:rPr sz="980">
-                <a:solidFill>
-                  <a:srgbClr val="0F172A"/>
-                </a:solidFill>
-                <a:latin typeface="Arial"/>
-              </a:rPr>
-              <a:t>Captures urgent vs saver fares weighted dynamically by official DGCA passenger volumes.</a:t>
-            </a:r>
-          </a:p>
-          <a:p>
-            <a:pPr>
-              <a:lnSpc>
-                <a:spcPct val="115000"/>
-              </a:lnSpc>
-              <a:spcAft>
-                <a:spcPts val="500"/>
-              </a:spcAft>
-            </a:pPr>
-            <a:r>
-              <a:rPr sz="1019" b="1">
-                <a:solidFill>
-                  <a:srgbClr val="15803D"/>
-                </a:solidFill>
-                <a:latin typeface="Arial"/>
-              </a:rPr>
-              <a:t>• UN/ILO Jevons Index: </a:t>
-            </a:r>
-            <a:r>
-              <a:rPr sz="980">
-                <a:solidFill>
-                  <a:srgbClr val="0F172A"/>
-                </a:solidFill>
-                <a:latin typeface="Arial"/>
-              </a:rPr>
-              <a:t>Geometric mean formulation mathematically eliminates Dutot upward substitution distortion.</a:t>
-            </a:r>
-          </a:p>
-          <a:p>
-            <a:pPr>
-              <a:lnSpc>
-                <a:spcPct val="115000"/>
-              </a:lnSpc>
-              <a:spcAft>
-                <a:spcPts val="500"/>
-              </a:spcAft>
-            </a:pPr>
-            <a:r>
-              <a:rPr sz="1019" b="1">
-                <a:solidFill>
-                  <a:srgbClr val="15803D"/>
-                </a:solidFill>
-                <a:latin typeface="Arial"/>
-              </a:rPr>
-              <a:t>• SHA-256 Audit Ledger: </a:t>
-            </a:r>
-            <a:r>
-              <a:rPr sz="980">
-                <a:solidFill>
-                  <a:srgbClr val="0F172A"/>
-                </a:solidFill>
-                <a:latin typeface="Arial"/>
-              </a:rPr>
-              <a:t>Immutable cryptographic fingerprints ensure sovereign-grade evidentiary auditability for MoSPI.</a:t>
-            </a:r>
-          </a:p>
-        </p:txBody>
-      </p:sp>
-      <p:pic>
-        <p:nvPicPr>
-          <p:cNvPr id="13" name="Picture 12" descr="workflow_circular_nodes.png"/>
-          <p:cNvPicPr>
-            <a:picLocks noChangeAspect="1"/>
-          </p:cNvPicPr>
-          <p:nvPr/>
-        </p:nvPicPr>
-        <p:blipFill>
-          <a:blip r:embed="rId3"/>
-          <a:stretch>
-            <a:fillRect/>
-          </a:stretch>
-        </p:blipFill>
-        <p:spPr>
-          <a:xfrm>
-            <a:off x="502920" y="4069080"/>
-            <a:ext cx="11183112" cy="1755648"/>
-          </a:xfrm>
-          <a:prstGeom prst="rect">
-            <a:avLst/>
-          </a:prstGeom>
-        </p:spPr>
-      </p:pic>
-      <p:sp>
-        <p:nvSpPr>
-          <p:cNvPr id="14" name="Rounded Rectangle 13"/>
+              <a:defRPr sz="960">
+                <a:solidFill>
+                  <a:srgbClr val="1E293B"/>
+                </a:solidFill>
+                <a:latin typeface="Arial"/>
+              </a:defRPr>
+            </a:pPr>
+            <a:r>
+              <a:t>SHA-256 batch Merkle tree proofs for judicial and policy scrutiny.</a:t>
+            </a:r>
+          </a:p>
+        </p:txBody>
+      </p:sp>
+      <p:sp>
+        <p:nvSpPr>
+          <p:cNvPr id="31" name="Rounded Rectangle 30"/>
           <p:cNvSpPr/>
           <p:nvPr/>
         </p:nvSpPr>
         <p:spPr>
           <a:xfrm>
-            <a:off x="502920" y="5943600"/>
-            <a:ext cx="11183112" cy="438912"/>
+            <a:off x="7379208" y="6263640"/>
+            <a:ext cx="1956816" cy="310896"/>
           </a:xfrm>
           <a:prstGeom prst="roundRect">
             <a:avLst>
@@ -4194,11 +5157,11 @@
             </a:avLst>
           </a:prstGeom>
           <a:solidFill>
-            <a:srgbClr val="0F172A"/>
+            <a:srgbClr val="F0FDF4"/>
           </a:solidFill>
-          <a:ln w="15240">
+          <a:ln w="12700">
             <a:solidFill>
-              <a:srgbClr val="1E3A8A"/>
+              <a:srgbClr val="22C55E"/>
             </a:solidFill>
           </a:ln>
         </p:spPr>
@@ -4220,20 +5183,30 @@
           <a:bodyPr rtlCol="0" anchor="ctr"/>
           <a:lstStyle/>
           <a:p>
-            <a:pPr algn="ctr"/>
-          </a:p>
-        </p:txBody>
-      </p:sp>
-      <p:sp>
-        <p:nvSpPr>
-          <p:cNvPr id="15" name="TextBox 14"/>
+            <a:pPr algn="ctr">
+              <a:defRPr sz="850" b="1">
+                <a:solidFill>
+                  <a:srgbClr val="16A34A"/>
+                </a:solidFill>
+                <a:latin typeface="Arial"/>
+              </a:defRPr>
+            </a:pPr>
+            <a:r>
+              <a:t>SHA-256 Ledger | Tamper-Proof</a:t>
+            </a:r>
+          </a:p>
+        </p:txBody>
+      </p:sp>
+      <p:sp>
+        <p:nvSpPr>
+          <p:cNvPr id="32" name="TextBox 31"/>
           <p:cNvSpPr txBox="1"/>
           <p:nvPr/>
         </p:nvSpPr>
         <p:spPr>
           <a:xfrm>
-            <a:off x="594360" y="5998464"/>
-            <a:ext cx="11000232" cy="329184"/>
+            <a:off x="9418320" y="5001768"/>
+            <a:ext cx="146304" cy="365760"/>
           </a:xfrm>
           <a:prstGeom prst="rect">
             <a:avLst/>
@@ -4241,92 +5214,255 @@
           <a:noFill/>
         </p:spPr>
         <p:txBody>
-          <a:bodyPr wrap="none">
+          <a:bodyPr wrap="none" lIns="0" tIns="0" rIns="0" bIns="0">
             <a:spAutoFit/>
           </a:bodyPr>
           <a:lstStyle/>
           <a:p>
+            <a:pPr algn="ctr">
+              <a:defRPr sz="1500" b="1">
+                <a:solidFill>
+                  <a:srgbClr val="94A3B8"/>
+                </a:solidFill>
+                <a:latin typeface="Arial"/>
+              </a:defRPr>
+            </a:pPr>
+            <a:r>
+              <a:t>➔</a:t>
+            </a:r>
+          </a:p>
+        </p:txBody>
+      </p:sp>
+      <p:sp>
+        <p:nvSpPr>
+          <p:cNvPr id="33" name="Rounded Rectangle 32"/>
+          <p:cNvSpPr/>
+          <p:nvPr/>
+        </p:nvSpPr>
+        <p:spPr>
+          <a:xfrm>
+            <a:off x="9573768" y="3950208"/>
+            <a:ext cx="2103120" cy="2697480"/>
+          </a:xfrm>
+          <a:prstGeom prst="roundRect">
+            <a:avLst>
+              <a:gd name="adj" fmla="val 5000"/>
+            </a:avLst>
+          </a:prstGeom>
+          <a:solidFill>
+            <a:srgbClr val="FFFFFF"/>
+          </a:solidFill>
+          <a:ln w="19050">
+            <a:solidFill>
+              <a:srgbClr val="64748B"/>
+            </a:solidFill>
+          </a:ln>
+        </p:spPr>
+        <p:style>
+          <a:lnRef idx="1">
+            <a:schemeClr val="accent1"/>
+          </a:lnRef>
+          <a:fillRef idx="3">
+            <a:schemeClr val="accent1"/>
+          </a:fillRef>
+          <a:effectRef idx="2">
+            <a:schemeClr val="accent1"/>
+          </a:effectRef>
+          <a:fontRef idx="minor">
+            <a:schemeClr val="lt1"/>
+          </a:fontRef>
+        </p:style>
+        <p:txBody>
+          <a:bodyPr rtlCol="0" anchor="ctr"/>
+          <a:lstStyle/>
+          <a:p>
             <a:pPr algn="ctr"/>
-            <a:r>
-              <a:rPr sz="1050" b="1">
+          </a:p>
+        </p:txBody>
+      </p:sp>
+      <p:sp>
+        <p:nvSpPr>
+          <p:cNvPr id="34" name="Rounded Rectangle 33"/>
+          <p:cNvSpPr/>
+          <p:nvPr/>
+        </p:nvSpPr>
+        <p:spPr>
+          <a:xfrm>
+            <a:off x="9573768" y="3950208"/>
+            <a:ext cx="2103120" cy="365760"/>
+          </a:xfrm>
+          <a:prstGeom prst="roundRect">
+            <a:avLst>
+              <a:gd name="adj" fmla="val 18000"/>
+            </a:avLst>
+          </a:prstGeom>
+          <a:solidFill>
+            <a:srgbClr val="0F172A"/>
+          </a:solidFill>
+          <a:ln>
+            <a:noFill/>
+          </a:ln>
+        </p:spPr>
+        <p:style>
+          <a:lnRef idx="1">
+            <a:schemeClr val="accent1"/>
+          </a:lnRef>
+          <a:fillRef idx="3">
+            <a:schemeClr val="accent1"/>
+          </a:fillRef>
+          <a:effectRef idx="2">
+            <a:schemeClr val="accent1"/>
+          </a:effectRef>
+          <a:fontRef idx="minor">
+            <a:schemeClr val="lt1"/>
+          </a:fontRef>
+        </p:style>
+        <p:txBody>
+          <a:bodyPr rtlCol="0" anchor="ctr"/>
+          <a:lstStyle/>
+          <a:p>
+            <a:pPr algn="ctr">
+              <a:defRPr sz="1100" b="1">
                 <a:solidFill>
                   <a:srgbClr val="FFFFFF"/>
                 </a:solidFill>
                 <a:latin typeface="Arial"/>
-              </a:rPr>
-              <a:t>DATA HARVESTING</a:t>
-            </a:r>
-            <a:r>
-              <a:rPr sz="1050" b="1">
-                <a:solidFill>
-                  <a:srgbClr val="38BDF8"/>
-                </a:solidFill>
-                <a:latin typeface="Arial"/>
-              </a:rPr>
-              <a:t>  ➔  </a:t>
-            </a:r>
-            <a:r>
-              <a:rPr sz="1050" b="1">
-                <a:solidFill>
-                  <a:srgbClr val="FFFFFF"/>
-                </a:solidFill>
-                <a:latin typeface="Arial"/>
-              </a:rPr>
-              <a:t>IQR OUTLIER TRUNCATION</a:t>
-            </a:r>
-            <a:r>
-              <a:rPr sz="1050" b="1">
-                <a:solidFill>
-                  <a:srgbClr val="38BDF8"/>
-                </a:solidFill>
-                <a:latin typeface="Arial"/>
-              </a:rPr>
-              <a:t>  ➔  </a:t>
-            </a:r>
-            <a:r>
-              <a:rPr sz="1050" b="1">
-                <a:solidFill>
-                  <a:srgbClr val="FFFFFF"/>
-                </a:solidFill>
-                <a:latin typeface="Arial"/>
-              </a:rPr>
-              <a:t>JEVONS GEOMETRIC INDEX</a:t>
-            </a:r>
-            <a:r>
-              <a:rPr sz="1050" b="1">
-                <a:solidFill>
-                  <a:srgbClr val="38BDF8"/>
-                </a:solidFill>
-                <a:latin typeface="Arial"/>
-              </a:rPr>
-              <a:t>  ➔  </a:t>
-            </a:r>
-            <a:r>
-              <a:rPr sz="1050" b="1">
-                <a:solidFill>
-                  <a:srgbClr val="FFFFFF"/>
-                </a:solidFill>
-                <a:latin typeface="Arial"/>
-              </a:rPr>
-              <a:t>SHA-256 PROVENANCE</a:t>
-            </a:r>
-            <a:r>
-              <a:rPr sz="1050" b="1">
-                <a:solidFill>
-                  <a:srgbClr val="38BDF8"/>
-                </a:solidFill>
-                <a:latin typeface="Arial"/>
-              </a:rPr>
-              <a:t>  ➔  </a:t>
-            </a:r>
-            <a:r>
-              <a:rPr sz="1050" b="1">
-                <a:solidFill>
-                  <a:srgbClr val="FFFFFF"/>
-                </a:solidFill>
-                <a:latin typeface="Arial"/>
-              </a:rPr>
-              <a:t>MoSPI &amp; RBI CPI INTEGRATION</a:t>
+              </a:defRPr>
+            </a:pPr>
+            <a:r>
+              <a:t>STEP 05</a:t>
+            </a:r>
+          </a:p>
+        </p:txBody>
+      </p:sp>
+      <p:sp>
+        <p:nvSpPr>
+          <p:cNvPr id="35" name="TextBox 34"/>
+          <p:cNvSpPr txBox="1"/>
+          <p:nvPr/>
+        </p:nvSpPr>
+        <p:spPr>
+          <a:xfrm>
+            <a:off x="9665208" y="4361688"/>
+            <a:ext cx="1920240" cy="1828800"/>
+          </a:xfrm>
+          <a:prstGeom prst="rect">
+            <a:avLst/>
+          </a:prstGeom>
+          <a:noFill/>
+        </p:spPr>
+        <p:txBody>
+          <a:bodyPr wrap="square" tIns="0" bIns="0" lIns="0" rIns="0">
+            <a:spAutoFit/>
+          </a:bodyPr>
+          <a:lstStyle/>
+          <a:p>
+            <a:pPr algn="ctr">
+              <a:spcAft>
+                <a:spcPts val="200"/>
+              </a:spcAft>
+              <a:defRPr sz="1150" b="1">
+                <a:solidFill>
+                  <a:srgbClr val="0F172A"/>
+                </a:solidFill>
+                <a:latin typeface="Arial"/>
+              </a:defRPr>
+            </a:pPr>
+            <a:r>
+              <a:t>Real-Time API</a:t>
+            </a:r>
+            <a:br/>
+            <a:r>
+              <a:t>Delivery</a:t>
+            </a:r>
+          </a:p>
+          <a:p>
+            <a:pPr algn="ctr">
+              <a:spcAft>
+                <a:spcPts val="600"/>
+              </a:spcAft>
+              <a:defRPr sz="900" b="1">
+                <a:solidFill>
+                  <a:srgbClr val="64748B"/>
+                </a:solidFill>
+                <a:latin typeface="Arial"/>
+              </a:defRPr>
+            </a:pPr>
+            <a:r>
+              <a:t>• Instant Feeds •</a:t>
+            </a:r>
+          </a:p>
+          <a:p>
+            <a:pPr algn="l">
+              <a:lnSpc>
+                <a:spcPct val="118000"/>
+              </a:lnSpc>
+              <a:defRPr sz="960">
+                <a:solidFill>
+                  <a:srgbClr val="1E293B"/>
+                </a:solidFill>
+                <a:latin typeface="Arial"/>
+              </a:defRPr>
+            </a:pPr>
+            <a:r>
+              <a:t>Sub-10ms REST API and live eSankhyiki CSV feed for MoSPI and RBI.</a:t>
+            </a:r>
+          </a:p>
+        </p:txBody>
+      </p:sp>
+      <p:sp>
+        <p:nvSpPr>
+          <p:cNvPr id="36" name="Rounded Rectangle 35"/>
+          <p:cNvSpPr/>
+          <p:nvPr/>
+        </p:nvSpPr>
+        <p:spPr>
+          <a:xfrm>
+            <a:off x="9646920" y="6263640"/>
+            <a:ext cx="1956816" cy="310896"/>
+          </a:xfrm>
+          <a:prstGeom prst="roundRect">
+            <a:avLst>
+              <a:gd name="adj" fmla="val 20000"/>
+            </a:avLst>
+          </a:prstGeom>
+          <a:solidFill>
+            <a:srgbClr val="F8FAFC"/>
+          </a:solidFill>
+          <a:ln w="12700">
+            <a:solidFill>
+              <a:srgbClr val="64748B"/>
+            </a:solidFill>
+          </a:ln>
+        </p:spPr>
+        <p:style>
+          <a:lnRef idx="1">
+            <a:schemeClr val="accent1"/>
+          </a:lnRef>
+          <a:fillRef idx="3">
+            <a:schemeClr val="accent1"/>
+          </a:fillRef>
+          <a:effectRef idx="2">
+            <a:schemeClr val="accent1"/>
+          </a:effectRef>
+          <a:fontRef idx="minor">
+            <a:schemeClr val="lt1"/>
+          </a:fontRef>
+        </p:style>
+        <p:txBody>
+          <a:bodyPr rtlCol="0" anchor="ctr"/>
+          <a:lstStyle/>
+          <a:p>
+            <a:pPr algn="ctr">
+              <a:defRPr sz="850" b="1">
+                <a:solidFill>
+                  <a:srgbClr val="0F172A"/>
+                </a:solidFill>
+                <a:latin typeface="Arial"/>
+              </a:defRPr>
+            </a:pPr>
+            <a:r>
+              <a:t>FastAPI &amp; CSV Feed | &lt; 10ms Latency</a:t>
             </a:r>
           </a:p>
         </p:txBody>

</xml_diff>